<commit_message>
add: T04 from spec 002-s02-architecture
</commit_message>
<xml_diff>
--- a/deliverables/S02/M4_Equipo06_S02_Arquitectura.pptx
+++ b/deliverables/S02/M4_Equipo06_S02_Arquitectura.pptx
@@ -4886,11 +4886,21 @@
         </p:spPr>
         <p:txBody>
           <a:bodyPr wrap="square" anchor="t" lIns="73152" rIns="73152" tIns="36576" bIns="36576">
-            <a:spAutoFit/>
+            <a:noAutofit/>
           </a:bodyPr>
           <a:lstStyle/>
           <a:p>
-            <a:pPr algn="l"/>
+            <a:pPr algn="l">
+              <a:lnSpc>
+                <a:spcPct val="100000"/>
+              </a:lnSpc>
+              <a:spcBef>
+                <a:spcPts val="0"/>
+              </a:spcBef>
+              <a:spcAft>
+                <a:spcPts val="0"/>
+              </a:spcAft>
+            </a:pPr>
             <a:r>
               <a:rPr sz="1100" b="1" i="0">
                 <a:solidFill>
@@ -4898,7 +4908,7 @@
                 </a:solidFill>
                 <a:latin typeface="Calibri"/>
               </a:rPr>
-              <a:t>PROYECTO INTEGRADOR · HITO S02 · EQUIPO XX</a:t>
+              <a:t>PROYECTO INTEGRADOR · HITO S02 · EQUIPO 06</a:t>
             </a:r>
           </a:p>
         </p:txBody>
@@ -5002,7 +5012,7 @@
         </p:spPr>
         <p:txBody>
           <a:bodyPr wrap="square" anchor="t" lIns="73152" rIns="73152" tIns="36576" bIns="36576">
-            <a:spAutoFit/>
+            <a:noAutofit/>
           </a:bodyPr>
           <a:lstStyle/>
           <a:p>
@@ -5018,15 +5028,25 @@
             </a:r>
           </a:p>
           <a:p>
-            <a:pPr algn="l"/>
-            <a:r>
-              <a:rPr sz="1300" b="0" i="1">
+            <a:pPr algn="l">
+              <a:lnSpc>
+                <a:spcPct val="95000"/>
+              </a:lnSpc>
+              <a:spcBef>
+                <a:spcPts val="0"/>
+              </a:spcBef>
+              <a:spcAft>
+                <a:spcPts val="0"/>
+              </a:spcAft>
+            </a:pPr>
+            <a:r>
+              <a:rPr sz="1100" b="0" i="0">
                 <a:solidFill>
                   <a:srgbClr val="52606D"/>
                 </a:solidFill>
                 <a:latin typeface="Calibri"/>
               </a:rPr>
-              <a:t>Escriba aquí la decisión en una frase: quién decide, qué decide y cada cuánto.</a:t>
+              <a:t>La Jefatura de Operaciones decide cada semana dónde priorizar controles térmicos por producto y camión y qué lotes o centros revisar por vencimiento y merma.</a:t>
             </a:r>
           </a:p>
         </p:txBody>
@@ -5130,19 +5150,51 @@
         </p:spPr>
         <p:txBody>
           <a:bodyPr wrap="square" anchor="t" lIns="73152" rIns="73152" tIns="36576" bIns="36576">
-            <a:spAutoFit/>
+            <a:noAutofit/>
           </a:bodyPr>
           <a:lstStyle/>
           <a:p>
-            <a:pPr algn="l"/>
-            <a:r>
-              <a:rPr sz="1250" b="0" i="1">
+            <a:pPr algn="l">
+              <a:lnSpc>
+                <a:spcPct val="95000"/>
+              </a:lnSpc>
+              <a:spcBef>
+                <a:spcPts val="0"/>
+              </a:spcBef>
+              <a:spcAft>
+                <a:spcPts val="0"/>
+              </a:spcAft>
+            </a:pPr>
+            <a:r>
+              <a:rPr sz="950" b="0" i="0">
                 <a:solidFill>
                   <a:srgbClr val="52606D"/>
                 </a:solidFill>
                 <a:latin typeface="Calibri"/>
               </a:rPr>
-              <a:t>¿De qué sistema vienen los datos? (ERP, SCADA, CRM, WMS…)</a:t>
+              <a:t>No documentado por archivo; por acordar.</a:t>
+            </a:r>
+          </a:p>
+          <a:p>
+            <a:pPr algn="l">
+              <a:lnSpc>
+                <a:spcPct val="95000"/>
+              </a:lnSpc>
+              <a:spcBef>
+                <a:spcPts val="0"/>
+              </a:spcBef>
+              <a:spcAft>
+                <a:spcPts val="0"/>
+              </a:spcAft>
+            </a:pPr>
+            <a:r>
+              <a:rPr sz="950" b="0" i="0">
+                <a:solidFill>
+                  <a:srgbClr val="52606D"/>
+                </a:solidFill>
+                <a:latin typeface="Calibri"/>
+              </a:rPr>
+              <a:t>No se atribuye ERP, WMS, TMS ni telemetría a estas tablas.</a:t>
             </a:r>
           </a:p>
         </p:txBody>
@@ -5289,19 +5341,51 @@
         </p:spPr>
         <p:txBody>
           <a:bodyPr wrap="square" anchor="t" lIns="73152" rIns="73152" tIns="36576" bIns="36576">
-            <a:spAutoFit/>
+            <a:noAutofit/>
           </a:bodyPr>
           <a:lstStyle/>
           <a:p>
-            <a:pPr algn="l"/>
-            <a:r>
-              <a:rPr sz="1250" b="0" i="1">
+            <a:pPr algn="l">
+              <a:lnSpc>
+                <a:spcPct val="95000"/>
+              </a:lnSpc>
+              <a:spcBef>
+                <a:spcPts val="0"/>
+              </a:spcBef>
+              <a:spcAft>
+                <a:spcPts val="0"/>
+              </a:spcAft>
+            </a:pPr>
+            <a:r>
+              <a:rPr sz="950" b="0" i="0">
                 <a:solidFill>
                   <a:srgbClr val="52606D"/>
                 </a:solidFill>
                 <a:latin typeface="Calibri"/>
               </a:rPr>
-              <a:t>¿Qué archivos Silver usan? ¿Qué representa una fila de cada uno?</a:t>
+              <a:t>5 fuentes oficiales: DATA-001 a DATA-005.</a:t>
+            </a:r>
+          </a:p>
+          <a:p>
+            <a:pPr algn="l">
+              <a:lnSpc>
+                <a:spcPct val="95000"/>
+              </a:lnSpc>
+              <a:spcBef>
+                <a:spcPts val="0"/>
+              </a:spcBef>
+              <a:spcAft>
+                <a:spcPts val="0"/>
+              </a:spcAft>
+            </a:pPr>
+            <a:r>
+              <a:rPr sz="950" b="0" i="0">
+                <a:solidFill>
+                  <a:srgbClr val="52606D"/>
+                </a:solidFill>
+                <a:latin typeface="Calibri"/>
+              </a:rPr>
+              <a:t>Una fila = una lectura, producto, camión, lote o centro-mes.</a:t>
             </a:r>
           </a:p>
         </p:txBody>
@@ -5448,19 +5532,51 @@
         </p:spPr>
         <p:txBody>
           <a:bodyPr wrap="square" anchor="t" lIns="73152" rIns="73152" tIns="36576" bIns="36576">
-            <a:spAutoFit/>
+            <a:noAutofit/>
           </a:bodyPr>
           <a:lstStyle/>
           <a:p>
-            <a:pPr algn="l"/>
-            <a:r>
-              <a:rPr sz="1250" b="0" i="1">
+            <a:pPr algn="l">
+              <a:lnSpc>
+                <a:spcPct val="95000"/>
+              </a:lnSpc>
+              <a:spcBef>
+                <a:spcPts val="0"/>
+              </a:spcBef>
+              <a:spcAft>
+                <a:spcPts val="0"/>
+              </a:spcAft>
+            </a:pPr>
+            <a:r>
+              <a:rPr sz="900" b="0" i="0">
                 <a:solidFill>
                   <a:srgbClr val="52606D"/>
                 </a:solidFill>
                 <a:latin typeface="Calibri"/>
               </a:rPr>
-              <a:t>¿Qué corrigen antes de cargar? (región, tipos, vacíos, códigos)</a:t>
+              <a:t>RutaSilver + File.Contents + Csv.Document; Encabezados y Tipado.</a:t>
+            </a:r>
+          </a:p>
+          <a:p>
+            <a:pPr algn="l">
+              <a:lnSpc>
+                <a:spcPct val="95000"/>
+              </a:lnSpc>
+              <a:spcBef>
+                <a:spcPts val="0"/>
+              </a:spcBef>
+              <a:spcAft>
+                <a:spcPts val="0"/>
+              </a:spcAft>
+            </a:pPr>
+            <a:r>
+              <a:rPr sz="900" b="0" i="0">
+                <a:solidFill>
+                  <a:srgbClr val="52606D"/>
+                </a:solidFill>
+                <a:latin typeface="Calibri"/>
+              </a:rPr>
+              <a:t>Ya existente; sin cambios en S02.</a:t>
             </a:r>
           </a:p>
         </p:txBody>
@@ -5607,19 +5723,51 @@
         </p:spPr>
         <p:txBody>
           <a:bodyPr wrap="square" anchor="t" lIns="73152" rIns="73152" tIns="36576" bIns="36576">
-            <a:spAutoFit/>
+            <a:noAutofit/>
           </a:bodyPr>
           <a:lstStyle/>
           <a:p>
-            <a:pPr algn="l"/>
-            <a:r>
-              <a:rPr sz="1250" b="0" i="1">
+            <a:pPr algn="l">
+              <a:lnSpc>
+                <a:spcPct val="95000"/>
+              </a:lnSpc>
+              <a:spcBef>
+                <a:spcPts val="0"/>
+              </a:spcBef>
+              <a:spcAft>
+                <a:spcPts val="0"/>
+              </a:spcAft>
+            </a:pPr>
+            <a:r>
+              <a:rPr sz="950" b="0" i="0">
                 <a:solidFill>
                   <a:srgbClr val="52606D"/>
                 </a:solidFill>
                 <a:latin typeface="Calibri"/>
               </a:rPr>
-              <a:t>¿Qué tablas se relacionan y por qué columna? (Importación)</a:t>
+              <a:t>5 tablas Import; 0 relaciones; 0 medidas.</a:t>
+            </a:r>
+          </a:p>
+          <a:p>
+            <a:pPr algn="l">
+              <a:lnSpc>
+                <a:spcPct val="95000"/>
+              </a:lnSpc>
+              <a:spcBef>
+                <a:spcPts val="0"/>
+              </a:spcBef>
+              <a:spcAft>
+                <a:spcPts val="0"/>
+              </a:spcAft>
+            </a:pPr>
+            <a:r>
+              <a:rPr sz="950" b="0" i="0">
+                <a:solidFill>
+                  <a:srgbClr val="52606D"/>
+                </a:solidFill>
+                <a:latin typeface="Calibri"/>
+              </a:rPr>
+              <a:t>Modelo relacional: dimensiones y relaciones, propuestas para S06.</a:t>
             </a:r>
           </a:p>
         </p:txBody>
@@ -5766,19 +5914,51 @@
         </p:spPr>
         <p:txBody>
           <a:bodyPr wrap="square" anchor="t" lIns="73152" rIns="73152" tIns="36576" bIns="36576">
-            <a:spAutoFit/>
+            <a:noAutofit/>
           </a:bodyPr>
           <a:lstStyle/>
           <a:p>
-            <a:pPr algn="l"/>
-            <a:r>
-              <a:rPr sz="1250" b="0" i="1">
+            <a:pPr algn="l">
+              <a:lnSpc>
+                <a:spcPct val="95000"/>
+              </a:lnSpc>
+              <a:spcBef>
+                <a:spcPts val="0"/>
+              </a:spcBef>
+              <a:spcAft>
+                <a:spcPts val="0"/>
+              </a:spcAft>
+            </a:pPr>
+            <a:r>
+              <a:rPr sz="1000" b="0" i="0">
                 <a:solidFill>
                   <a:srgbClr val="52606D"/>
                 </a:solidFill>
                 <a:latin typeface="Calibri"/>
               </a:rPr>
-              <a:t>¿Qué KPI ve quien decide? Use uno de su hoja «Fichas KPI».</a:t>
+              <a:t>% de viajes con desviación.</a:t>
+            </a:r>
+          </a:p>
+          <a:p>
+            <a:pPr algn="l">
+              <a:lnSpc>
+                <a:spcPct val="95000"/>
+              </a:lnSpc>
+              <a:spcBef>
+                <a:spcPts val="0"/>
+              </a:spcBef>
+              <a:spcAft>
+                <a:spcPts val="0"/>
+              </a:spcAft>
+            </a:pPr>
+            <a:r>
+              <a:rPr sz="1000" b="0" i="0">
+                <a:solidFill>
+                  <a:srgbClr val="52606D"/>
+                </a:solidFill>
+                <a:latin typeface="Calibri"/>
+              </a:rPr>
+              <a:t>Nivel táctico; fórmula y unidad en Fichas KPI.</a:t>
             </a:r>
           </a:p>
         </p:txBody>
@@ -5884,19 +6064,73 @@
         </p:spPr>
         <p:txBody>
           <a:bodyPr wrap="square" anchor="t" lIns="73152" rIns="73152" tIns="36576" bIns="36576">
-            <a:spAutoFit/>
+            <a:noAutofit/>
           </a:bodyPr>
           <a:lstStyle/>
           <a:p>
-            <a:pPr algn="l"/>
-            <a:r>
-              <a:rPr sz="1200" b="0" i="1">
+            <a:pPr algn="l">
+              <a:lnSpc>
+                <a:spcPct val="95000"/>
+              </a:lnSpc>
+              <a:spcBef>
+                <a:spcPts val="0"/>
+              </a:spcBef>
+              <a:spcAft>
+                <a:spcPts val="0"/>
+              </a:spcAft>
+            </a:pPr>
+            <a:r>
+              <a:rPr sz="900" b="0" i="0">
                 <a:solidFill>
                   <a:srgbClr val="52606D"/>
                 </a:solidFill>
                 <a:latin typeface="Calibri"/>
               </a:rPr>
-              <a:t>La brecha priorizada en el hito S01: hecho, componente, dimensión y puntaje.</a:t>
+              <a:t>No encontramos definición explícita de centro_distribucion.</a:t>
+            </a:r>
+          </a:p>
+          <a:p>
+            <a:pPr algn="l">
+              <a:lnSpc>
+                <a:spcPct val="95000"/>
+              </a:lnSpc>
+              <a:spcBef>
+                <a:spcPts val="0"/>
+              </a:spcBef>
+              <a:spcAft>
+                <a:spcPts val="0"/>
+              </a:spcAft>
+            </a:pPr>
+            <a:r>
+              <a:rPr sz="900" b="0" i="0">
+                <a:solidFill>
+                  <a:srgbClr val="52606D"/>
+                </a:solidFill>
+                <a:latin typeface="Calibri"/>
+              </a:rPr>
+              <a:t>C4 Conocimiento de los datos · Evidencia · 1 Incipiente.</a:t>
+            </a:r>
+          </a:p>
+          <a:p>
+            <a:pPr algn="l">
+              <a:lnSpc>
+                <a:spcPct val="95000"/>
+              </a:lnSpc>
+              <a:spcBef>
+                <a:spcPts val="0"/>
+              </a:spcBef>
+              <a:spcAft>
+                <a:spcPts val="0"/>
+              </a:spcAft>
+            </a:pPr>
+            <a:r>
+              <a:rPr sz="900" b="0" i="0">
+                <a:solidFill>
+                  <a:srgbClr val="52606D"/>
+                </a:solidFill>
+                <a:latin typeface="Calibri"/>
+              </a:rPr>
+              <a:t>Ausencia documentada; no resuelta.</a:t>
             </a:r>
           </a:p>
         </p:txBody>
@@ -6002,19 +6236,95 @@
         </p:spPr>
         <p:txBody>
           <a:bodyPr wrap="square" anchor="t" lIns="73152" rIns="73152" tIns="36576" bIns="36576">
-            <a:spAutoFit/>
+            <a:noAutofit/>
           </a:bodyPr>
           <a:lstStyle/>
           <a:p>
-            <a:pPr algn="l"/>
-            <a:r>
-              <a:rPr sz="1200" b="0" i="1">
+            <a:pPr algn="l">
+              <a:lnSpc>
+                <a:spcPct val="90000"/>
+              </a:lnSpc>
+              <a:spcBef>
+                <a:spcPts val="0"/>
+              </a:spcBef>
+              <a:spcAft>
+                <a:spcPts val="0"/>
+              </a:spcAft>
+            </a:pPr>
+            <a:r>
+              <a:rPr sz="800" b="0" i="0">
                 <a:solidFill>
                   <a:srgbClr val="52606D"/>
                 </a:solidFill>
                 <a:latin typeface="Calibri"/>
               </a:rPr>
-              <a:t>¿Qué podría hacer que el KPI salga mal, y qué regla lo evita?</a:t>
+              <a:t>Riesgo: interpretar mal qué representa el centro y usarlo en filtros o conclusiones.</a:t>
+            </a:r>
+          </a:p>
+          <a:p>
+            <a:pPr algn="l">
+              <a:lnSpc>
+                <a:spcPct val="90000"/>
+              </a:lnSpc>
+              <a:spcBef>
+                <a:spcPts val="0"/>
+              </a:spcBef>
+              <a:spcAft>
+                <a:spcPts val="0"/>
+              </a:spcAft>
+            </a:pPr>
+            <a:r>
+              <a:rPr sz="800" b="0" i="0">
+                <a:solidFill>
+                  <a:srgbClr val="52606D"/>
+                </a:solidFill>
+                <a:latin typeface="Calibri"/>
+              </a:rPr>
+              <a:t>Hecho: 8.000/8.000 viajes emparejados sin discrepancias: centro WMS = centro base; no prueba significado empresarial.</a:t>
+            </a:r>
+          </a:p>
+          <a:p>
+            <a:pPr algn="l">
+              <a:lnSpc>
+                <a:spcPct val="90000"/>
+              </a:lnSpc>
+              <a:spcBef>
+                <a:spcPts val="0"/>
+              </a:spcBef>
+              <a:spcAft>
+                <a:spcPts val="0"/>
+              </a:spcAft>
+            </a:pPr>
+            <a:r>
+              <a:rPr sz="800" b="0" i="0">
+                <a:solidFill>
+                  <a:srgbClr val="52606D"/>
+                </a:solidFill>
+                <a:latin typeface="Calibri"/>
+              </a:rPr>
+              <a:t>Control: documentar ausencia, usos y límites conocidos; solicitar definición y validación empresarial.</a:t>
+            </a:r>
+          </a:p>
+          <a:p>
+            <a:pPr algn="l">
+              <a:lnSpc>
+                <a:spcPct val="90000"/>
+              </a:lnSpc>
+              <a:spcBef>
+                <a:spcPts val="0"/>
+              </a:spcBef>
+              <a:spcAft>
+                <a:spcPts val="0"/>
+              </a:spcAft>
+            </a:pPr>
+            <a:r>
+              <a:rPr sz="800" b="0" i="0">
+                <a:solidFill>
+                  <a:srgbClr val="52606D"/>
+                </a:solidFill>
+                <a:latin typeface="Calibri"/>
+              </a:rPr>
+              <a:t>Complemento: no usar centro_distribucion_base como ruta u origen real; dim_centro y controles de claves, propuestas posteriores.</a:t>
             </a:r>
           </a:p>
         </p:txBody>
@@ -6120,19 +6430,29 @@
         </p:spPr>
         <p:txBody>
           <a:bodyPr wrap="square" anchor="t" lIns="73152" rIns="73152" tIns="36576" bIns="36576">
-            <a:spAutoFit/>
+            <a:noAutofit/>
           </a:bodyPr>
           <a:lstStyle/>
           <a:p>
-            <a:pPr algn="l"/>
-            <a:r>
-              <a:rPr sz="1200" b="0" i="1">
+            <a:pPr algn="l">
+              <a:lnSpc>
+                <a:spcPct val="95000"/>
+              </a:lnSpc>
+              <a:spcBef>
+                <a:spcPts val="0"/>
+              </a:spcBef>
+              <a:spcAft>
+                <a:spcPts val="0"/>
+              </a:spcAft>
+            </a:pPr>
+            <a:r>
+              <a:rPr sz="950" b="0" i="0">
                 <a:solidFill>
                   <a:srgbClr val="52606D"/>
                 </a:solidFill>
                 <a:latin typeface="Calibri"/>
               </a:rPr>
-              <a:t>Lo que todavía no pudieron comprobar y quién del equipo se encarga.</a:t>
+              <a:t>Definición y validación empresarial de centro_distribucion; seguimiento Grupo 06; validador por acordar. No resuelto.</a:t>
             </a:r>
           </a:p>
         </p:txBody>

</xml_diff>

<commit_message>
add: T05 from spec 002-s02-architecture
</commit_message>
<xml_diff>
--- a/deliverables/S02/M4_Equipo06_S02_Arquitectura.pptx
+++ b/deliverables/S02/M4_Equipo06_S02_Arquitectura.pptx
@@ -7,6 +7,8 @@
   <p:sldIdLst>
     <p:sldId id="256" r:id="rId7"/>
     <p:sldId id="257" r:id="rId9"/>
+    <p:sldId id="258" r:id="rId10"/>
+    <p:sldId id="259" r:id="rId11"/>
   </p:sldIdLst>
   <p:sldSz cx="12191695" cy="6858000" type="screen4x3"/>
   <p:notesSz cx="6858000" cy="9144000"/>
@@ -6457,6 +6459,3161 @@
           </a:p>
         </p:txBody>
       </p:sp>
+    </p:spTree>
+  </p:cSld>
+  <p:clrMapOvr>
+    <a:masterClrMapping/>
+  </p:clrMapOvr>
+</p:sld>
+</file>
+
+<file path=ppt/slides/slide3.xml><?xml version="1.0" encoding="utf-8"?>
+<p:sld xmlns:a="http://schemas.openxmlformats.org/drawingml/2006/main" xmlns:p="http://schemas.openxmlformats.org/presentationml/2006/main" xmlns:r="http://schemas.openxmlformats.org/officeDocument/2006/relationships">
+  <p:cSld>
+    <p:spTree>
+      <p:nvGrpSpPr>
+        <p:cNvPr id="1" name=""/>
+        <p:cNvGrpSpPr/>
+        <p:nvPr/>
+      </p:nvGrpSpPr>
+      <p:grpSpPr/>
+      <p:sp>
+        <p:nvSpPr>
+          <p:cNvPr id="2" name="Mapa Silver - texto"/>
+          <p:cNvSpPr txBox="1"/>
+          <p:nvPr/>
+        </p:nvSpPr>
+        <p:spPr>
+          <a:xfrm>
+            <a:off x="320040" y="164592"/>
+            <a:ext cx="11548872" cy="201168"/>
+          </a:xfrm>
+          <a:prstGeom prst="rect">
+            <a:avLst/>
+          </a:prstGeom>
+          <a:noFill/>
+        </p:spPr>
+        <p:txBody>
+          <a:bodyPr wrap="square" lIns="0" rIns="0" tIns="0" bIns="0">
+            <a:spAutoFit/>
+          </a:bodyPr>
+          <a:lstStyle/>
+          <a:p>
+            <a:pPr algn="l">
+              <a:spcBef>
+                <a:spcPts val="0"/>
+              </a:spcBef>
+              <a:spcAft>
+                <a:spcPts val="0"/>
+              </a:spcAft>
+            </a:pPr>
+            <a:r>
+              <a:rPr sz="950" b="1">
+                <a:solidFill>
+                  <a:srgbClr val="E87722"/>
+                </a:solidFill>
+                <a:latin typeface="Calibri"/>
+              </a:rPr>
+              <a:t>PROYECTO INTEGRADOR · HITO S02 · EQUIPO 06</a:t>
+            </a:r>
+          </a:p>
+        </p:txBody>
+      </p:sp>
+      <p:sp>
+        <p:nvSpPr>
+          <p:cNvPr id="3" name="Mapa Silver - texto"/>
+          <p:cNvSpPr txBox="1"/>
+          <p:nvPr/>
+        </p:nvSpPr>
+        <p:spPr>
+          <a:xfrm>
+            <a:off x="320040" y="384048"/>
+            <a:ext cx="10607040" cy="420624"/>
+          </a:xfrm>
+          <a:prstGeom prst="rect">
+            <a:avLst/>
+          </a:prstGeom>
+          <a:noFill/>
+        </p:spPr>
+        <p:txBody>
+          <a:bodyPr wrap="square" lIns="0" rIns="0" tIns="0" bIns="0">
+            <a:spAutoFit/>
+          </a:bodyPr>
+          <a:lstStyle/>
+          <a:p>
+            <a:pPr algn="l">
+              <a:spcBef>
+                <a:spcPts val="0"/>
+              </a:spcBef>
+              <a:spcAft>
+                <a:spcPts val="0"/>
+              </a:spcAft>
+            </a:pPr>
+            <a:r>
+              <a:rPr sz="2400" b="1">
+                <a:solidFill>
+                  <a:srgbClr val="1F3A4D"/>
+                </a:solidFill>
+                <a:latin typeface="Calibri"/>
+              </a:rPr>
+              <a:t>Mapa Silver — 1/2</a:t>
+            </a:r>
+          </a:p>
+        </p:txBody>
+      </p:sp>
+      <p:sp>
+        <p:nvSpPr>
+          <p:cNvPr id="4" name="Mapa Silver - línea de acento"/>
+          <p:cNvSpPr/>
+          <p:nvPr/>
+        </p:nvSpPr>
+        <p:spPr>
+          <a:xfrm>
+            <a:off x="320040" y="841248"/>
+            <a:ext cx="11548872" cy="32004"/>
+          </a:xfrm>
+          <a:prstGeom prst="rect">
+            <a:avLst/>
+          </a:prstGeom>
+          <a:solidFill>
+            <a:srgbClr val="E87722"/>
+          </a:solidFill>
+          <a:ln>
+            <a:noFill/>
+          </a:ln>
+        </p:spPr>
+        <p:style>
+          <a:lnRef idx="1">
+            <a:schemeClr val="accent1"/>
+          </a:lnRef>
+          <a:fillRef idx="3">
+            <a:schemeClr val="accent1"/>
+          </a:fillRef>
+          <a:effectRef idx="2">
+            <a:schemeClr val="accent1"/>
+          </a:effectRef>
+          <a:fontRef idx="minor">
+            <a:schemeClr val="lt1"/>
+          </a:fontRef>
+        </p:style>
+        <p:txBody>
+          <a:bodyPr rtlCol="0" anchor="ctr"/>
+          <a:lstStyle/>
+          <a:p>
+            <a:pPr algn="ctr"/>
+          </a:p>
+        </p:txBody>
+      </p:sp>
+      <p:graphicFrame>
+        <p:nvGraphicFramePr>
+          <p:cNvPr id="5" name="Tabla Mapa Silver 1/2"/>
+          <p:cNvGraphicFramePr>
+            <a:graphicFrameLocks noGrp="1"/>
+          </p:cNvGraphicFramePr>
+          <p:nvPr/>
+        </p:nvGraphicFramePr>
+        <p:xfrm>
+          <a:off x="320040" y="932688"/>
+          <a:ext cx="11548872" cy="5029200"/>
+        </p:xfrm>
+        <a:graphic>
+          <a:graphicData uri="http://schemas.openxmlformats.org/drawingml/2006/table">
+            <a:tbl>
+              <a:tblPr firstRow="1"/>
+              <a:tblGrid>
+                <a:gridCol w="2331720"/>
+                <a:gridCol w="1152144"/>
+                <a:gridCol w="1554480"/>
+                <a:gridCol w="1883664"/>
+                <a:gridCol w="1097280"/>
+                <a:gridCol w="1645920"/>
+                <a:gridCol w="1883664"/>
+              </a:tblGrid>
+              <a:tr h="502920">
+                <a:tc>
+                  <a:txBody>
+                    <a:bodyPr wrap="square"/>
+                    <a:lstStyle/>
+                    <a:p>
+                      <a:pPr algn="ctr">
+                        <a:lnSpc>
+                          <a:spcPct val="100000"/>
+                        </a:lnSpc>
+                        <a:spcBef>
+                          <a:spcPts val="0"/>
+                        </a:spcBef>
+                        <a:spcAft>
+                          <a:spcPts val="0"/>
+                        </a:spcAft>
+                      </a:pPr>
+                      <a:r>
+                        <a:rPr sz="1050" b="1">
+                          <a:solidFill>
+                            <a:srgbClr val="FFFFFF"/>
+                          </a:solidFill>
+                          <a:latin typeface="Calibri"/>
+                        </a:rPr>
+                        <a:t>Archivo / tabla</a:t>
+                      </a:r>
+                    </a:p>
+                  </a:txBody>
+                  <a:tcPr anchor="ctr" marL="54864" marR="54864" marT="32004" marB="32004">
+                    <a:lnL w="9525" cap="flat" cmpd="sng" algn="ctr">
+                      <a:solidFill>
+                        <a:srgbClr val="FFFFFF"/>
+                      </a:solidFill>
+                      <a:prstDash val="solid"/>
+                    </a:lnL>
+                    <a:lnR w="9525" cap="flat" cmpd="sng" algn="ctr">
+                      <a:solidFill>
+                        <a:srgbClr val="FFFFFF"/>
+                      </a:solidFill>
+                      <a:prstDash val="solid"/>
+                    </a:lnR>
+                    <a:lnT w="9525" cap="flat" cmpd="sng" algn="ctr">
+                      <a:solidFill>
+                        <a:srgbClr val="FFFFFF"/>
+                      </a:solidFill>
+                      <a:prstDash val="solid"/>
+                    </a:lnT>
+                    <a:lnB w="9525" cap="flat" cmpd="sng" algn="ctr">
+                      <a:solidFill>
+                        <a:srgbClr val="FFFFFF"/>
+                      </a:solidFill>
+                      <a:prstDash val="solid"/>
+                    </a:lnB>
+                    <a:solidFill>
+                      <a:srgbClr val="243746"/>
+                    </a:solidFill>
+                  </a:tcPr>
+                </a:tc>
+                <a:tc>
+                  <a:txBody>
+                    <a:bodyPr wrap="square"/>
+                    <a:lstStyle/>
+                    <a:p>
+                      <a:pPr algn="ctr">
+                        <a:lnSpc>
+                          <a:spcPct val="100000"/>
+                        </a:lnSpc>
+                        <a:spcBef>
+                          <a:spcPts val="0"/>
+                        </a:spcBef>
+                        <a:spcAft>
+                          <a:spcPts val="0"/>
+                        </a:spcAft>
+                      </a:pPr>
+                      <a:r>
+                        <a:rPr sz="1050" b="1">
+                          <a:solidFill>
+                            <a:srgbClr val="FFFFFF"/>
+                          </a:solidFill>
+                          <a:latin typeface="Calibri"/>
+                        </a:rPr>
+                        <a:t>Granularidad</a:t>
+                      </a:r>
+                    </a:p>
+                  </a:txBody>
+                  <a:tcPr anchor="ctr" marL="54864" marR="54864" marT="32004" marB="32004">
+                    <a:lnL w="9525" cap="flat" cmpd="sng" algn="ctr">
+                      <a:solidFill>
+                        <a:srgbClr val="FFFFFF"/>
+                      </a:solidFill>
+                      <a:prstDash val="solid"/>
+                    </a:lnL>
+                    <a:lnR w="9525" cap="flat" cmpd="sng" algn="ctr">
+                      <a:solidFill>
+                        <a:srgbClr val="FFFFFF"/>
+                      </a:solidFill>
+                      <a:prstDash val="solid"/>
+                    </a:lnR>
+                    <a:lnT w="9525" cap="flat" cmpd="sng" algn="ctr">
+                      <a:solidFill>
+                        <a:srgbClr val="FFFFFF"/>
+                      </a:solidFill>
+                      <a:prstDash val="solid"/>
+                    </a:lnT>
+                    <a:lnB w="9525" cap="flat" cmpd="sng" algn="ctr">
+                      <a:solidFill>
+                        <a:srgbClr val="FFFFFF"/>
+                      </a:solidFill>
+                      <a:prstDash val="solid"/>
+                    </a:lnB>
+                    <a:solidFill>
+                      <a:srgbClr val="243746"/>
+                    </a:solidFill>
+                  </a:tcPr>
+                </a:tc>
+                <a:tc>
+                  <a:txBody>
+                    <a:bodyPr wrap="square"/>
+                    <a:lstStyle/>
+                    <a:p>
+                      <a:pPr algn="ctr">
+                        <a:lnSpc>
+                          <a:spcPct val="100000"/>
+                        </a:lnSpc>
+                        <a:spcBef>
+                          <a:spcPts val="0"/>
+                        </a:spcBef>
+                        <a:spcAft>
+                          <a:spcPts val="0"/>
+                        </a:spcAft>
+                      </a:pPr>
+                      <a:r>
+                        <a:rPr sz="1050" b="1">
+                          <a:solidFill>
+                            <a:srgbClr val="FFFFFF"/>
+                          </a:solidFill>
+                          <a:latin typeface="Calibri"/>
+                        </a:rPr>
+                        <a:t>Identificador único</a:t>
+                      </a:r>
+                    </a:p>
+                  </a:txBody>
+                  <a:tcPr anchor="ctr" marL="54864" marR="54864" marT="32004" marB="32004">
+                    <a:lnL w="9525" cap="flat" cmpd="sng" algn="ctr">
+                      <a:solidFill>
+                        <a:srgbClr val="FFFFFF"/>
+                      </a:solidFill>
+                      <a:prstDash val="solid"/>
+                    </a:lnL>
+                    <a:lnR w="9525" cap="flat" cmpd="sng" algn="ctr">
+                      <a:solidFill>
+                        <a:srgbClr val="FFFFFF"/>
+                      </a:solidFill>
+                      <a:prstDash val="solid"/>
+                    </a:lnR>
+                    <a:lnT w="9525" cap="flat" cmpd="sng" algn="ctr">
+                      <a:solidFill>
+                        <a:srgbClr val="FFFFFF"/>
+                      </a:solidFill>
+                      <a:prstDash val="solid"/>
+                    </a:lnT>
+                    <a:lnB w="9525" cap="flat" cmpd="sng" algn="ctr">
+                      <a:solidFill>
+                        <a:srgbClr val="FFFFFF"/>
+                      </a:solidFill>
+                      <a:prstDash val="solid"/>
+                    </a:lnB>
+                    <a:solidFill>
+                      <a:srgbClr val="243746"/>
+                    </a:solidFill>
+                  </a:tcPr>
+                </a:tc>
+                <a:tc>
+                  <a:txBody>
+                    <a:bodyPr wrap="square"/>
+                    <a:lstStyle/>
+                    <a:p>
+                      <a:pPr algn="ctr">
+                        <a:lnSpc>
+                          <a:spcPct val="100000"/>
+                        </a:lnSpc>
+                        <a:spcBef>
+                          <a:spcPts val="0"/>
+                        </a:spcBef>
+                        <a:spcAft>
+                          <a:spcPts val="0"/>
+                        </a:spcAft>
+                      </a:pPr>
+                      <a:r>
+                        <a:rPr sz="1050" b="1">
+                          <a:solidFill>
+                            <a:srgbClr val="FFFFFF"/>
+                          </a:solidFill>
+                          <a:latin typeface="Calibri"/>
+                        </a:rPr>
+                        <a:t>Frecuencia</a:t>
+                      </a:r>
+                    </a:p>
+                  </a:txBody>
+                  <a:tcPr anchor="ctr" marL="54864" marR="54864" marT="32004" marB="32004">
+                    <a:lnL w="9525" cap="flat" cmpd="sng" algn="ctr">
+                      <a:solidFill>
+                        <a:srgbClr val="FFFFFF"/>
+                      </a:solidFill>
+                      <a:prstDash val="solid"/>
+                    </a:lnL>
+                    <a:lnR w="9525" cap="flat" cmpd="sng" algn="ctr">
+                      <a:solidFill>
+                        <a:srgbClr val="FFFFFF"/>
+                      </a:solidFill>
+                      <a:prstDash val="solid"/>
+                    </a:lnR>
+                    <a:lnT w="9525" cap="flat" cmpd="sng" algn="ctr">
+                      <a:solidFill>
+                        <a:srgbClr val="FFFFFF"/>
+                      </a:solidFill>
+                      <a:prstDash val="solid"/>
+                    </a:lnT>
+                    <a:lnB w="9525" cap="flat" cmpd="sng" algn="ctr">
+                      <a:solidFill>
+                        <a:srgbClr val="FFFFFF"/>
+                      </a:solidFill>
+                      <a:prstDash val="solid"/>
+                    </a:lnB>
+                    <a:solidFill>
+                      <a:srgbClr val="243746"/>
+                    </a:solidFill>
+                  </a:tcPr>
+                </a:tc>
+                <a:tc>
+                  <a:txBody>
+                    <a:bodyPr wrap="square"/>
+                    <a:lstStyle/>
+                    <a:p>
+                      <a:pPr algn="ctr">
+                        <a:lnSpc>
+                          <a:spcPct val="100000"/>
+                        </a:lnSpc>
+                        <a:spcBef>
+                          <a:spcPts val="0"/>
+                        </a:spcBef>
+                        <a:spcAft>
+                          <a:spcPts val="0"/>
+                        </a:spcAft>
+                      </a:pPr>
+                      <a:r>
+                        <a:rPr sz="1050" b="1">
+                          <a:solidFill>
+                            <a:srgbClr val="FFFFFF"/>
+                          </a:solidFill>
+                          <a:latin typeface="Calibri"/>
+                        </a:rPr>
+                        <a:t>Propietario</a:t>
+                      </a:r>
+                    </a:p>
+                  </a:txBody>
+                  <a:tcPr anchor="ctr" marL="54864" marR="54864" marT="32004" marB="32004">
+                    <a:lnL w="9525" cap="flat" cmpd="sng" algn="ctr">
+                      <a:solidFill>
+                        <a:srgbClr val="FFFFFF"/>
+                      </a:solidFill>
+                      <a:prstDash val="solid"/>
+                    </a:lnL>
+                    <a:lnR w="9525" cap="flat" cmpd="sng" algn="ctr">
+                      <a:solidFill>
+                        <a:srgbClr val="FFFFFF"/>
+                      </a:solidFill>
+                      <a:prstDash val="solid"/>
+                    </a:lnR>
+                    <a:lnT w="9525" cap="flat" cmpd="sng" algn="ctr">
+                      <a:solidFill>
+                        <a:srgbClr val="FFFFFF"/>
+                      </a:solidFill>
+                      <a:prstDash val="solid"/>
+                    </a:lnT>
+                    <a:lnB w="9525" cap="flat" cmpd="sng" algn="ctr">
+                      <a:solidFill>
+                        <a:srgbClr val="FFFFFF"/>
+                      </a:solidFill>
+                      <a:prstDash val="solid"/>
+                    </a:lnB>
+                    <a:solidFill>
+                      <a:srgbClr val="243746"/>
+                    </a:solidFill>
+                  </a:tcPr>
+                </a:tc>
+                <a:tc>
+                  <a:txBody>
+                    <a:bodyPr wrap="square"/>
+                    <a:lstStyle/>
+                    <a:p>
+                      <a:pPr algn="ctr">
+                        <a:lnSpc>
+                          <a:spcPct val="100000"/>
+                        </a:lnSpc>
+                        <a:spcBef>
+                          <a:spcPts val="0"/>
+                        </a:spcBef>
+                        <a:spcAft>
+                          <a:spcPts val="0"/>
+                        </a:spcAft>
+                      </a:pPr>
+                      <a:r>
+                        <a:rPr sz="1050" b="1">
+                          <a:solidFill>
+                            <a:srgbClr val="FFFFFF"/>
+                          </a:solidFill>
+                          <a:latin typeface="Calibri"/>
+                        </a:rPr>
+                        <a:t>Riesgo</a:t>
+                      </a:r>
+                    </a:p>
+                  </a:txBody>
+                  <a:tcPr anchor="ctr" marL="54864" marR="54864" marT="32004" marB="32004">
+                    <a:lnL w="9525" cap="flat" cmpd="sng" algn="ctr">
+                      <a:solidFill>
+                        <a:srgbClr val="FFFFFF"/>
+                      </a:solidFill>
+                      <a:prstDash val="solid"/>
+                    </a:lnL>
+                    <a:lnR w="9525" cap="flat" cmpd="sng" algn="ctr">
+                      <a:solidFill>
+                        <a:srgbClr val="FFFFFF"/>
+                      </a:solidFill>
+                      <a:prstDash val="solid"/>
+                    </a:lnR>
+                    <a:lnT w="9525" cap="flat" cmpd="sng" algn="ctr">
+                      <a:solidFill>
+                        <a:srgbClr val="FFFFFF"/>
+                      </a:solidFill>
+                      <a:prstDash val="solid"/>
+                    </a:lnT>
+                    <a:lnB w="9525" cap="flat" cmpd="sng" algn="ctr">
+                      <a:solidFill>
+                        <a:srgbClr val="FFFFFF"/>
+                      </a:solidFill>
+                      <a:prstDash val="solid"/>
+                    </a:lnB>
+                    <a:solidFill>
+                      <a:srgbClr val="243746"/>
+                    </a:solidFill>
+                  </a:tcPr>
+                </a:tc>
+                <a:tc>
+                  <a:txBody>
+                    <a:bodyPr wrap="square"/>
+                    <a:lstStyle/>
+                    <a:p>
+                      <a:pPr algn="ctr">
+                        <a:lnSpc>
+                          <a:spcPct val="100000"/>
+                        </a:lnSpc>
+                        <a:spcBef>
+                          <a:spcPts val="0"/>
+                        </a:spcBef>
+                        <a:spcAft>
+                          <a:spcPts val="0"/>
+                        </a:spcAft>
+                      </a:pPr>
+                      <a:r>
+                        <a:rPr sz="1050" b="1">
+                          <a:solidFill>
+                            <a:srgbClr val="FFFFFF"/>
+                          </a:solidFill>
+                          <a:latin typeface="Calibri"/>
+                        </a:rPr>
+                        <a:t>Control propuesto</a:t>
+                      </a:r>
+                    </a:p>
+                  </a:txBody>
+                  <a:tcPr anchor="ctr" marL="54864" marR="54864" marT="32004" marB="32004">
+                    <a:lnL w="9525" cap="flat" cmpd="sng" algn="ctr">
+                      <a:solidFill>
+                        <a:srgbClr val="FFFFFF"/>
+                      </a:solidFill>
+                      <a:prstDash val="solid"/>
+                    </a:lnL>
+                    <a:lnR w="9525" cap="flat" cmpd="sng" algn="ctr">
+                      <a:solidFill>
+                        <a:srgbClr val="FFFFFF"/>
+                      </a:solidFill>
+                      <a:prstDash val="solid"/>
+                    </a:lnR>
+                    <a:lnT w="9525" cap="flat" cmpd="sng" algn="ctr">
+                      <a:solidFill>
+                        <a:srgbClr val="FFFFFF"/>
+                      </a:solidFill>
+                      <a:prstDash val="solid"/>
+                    </a:lnT>
+                    <a:lnB w="9525" cap="flat" cmpd="sng" algn="ctr">
+                      <a:solidFill>
+                        <a:srgbClr val="FFFFFF"/>
+                      </a:solidFill>
+                      <a:prstDash val="solid"/>
+                    </a:lnB>
+                    <a:solidFill>
+                      <a:srgbClr val="243746"/>
+                    </a:solidFill>
+                  </a:tcPr>
+                </a:tc>
+              </a:tr>
+              <a:tr h="1508760">
+                <a:tc>
+                  <a:txBody>
+                    <a:bodyPr wrap="square"/>
+                    <a:lstStyle/>
+                    <a:p>
+                      <a:pPr algn="l">
+                        <a:lnSpc>
+                          <a:spcPct val="100000"/>
+                        </a:lnSpc>
+                        <a:spcBef>
+                          <a:spcPts val="0"/>
+                        </a:spcBef>
+                        <a:spcAft>
+                          <a:spcPts val="0"/>
+                        </a:spcAft>
+                      </a:pPr>
+                      <a:r>
+                        <a:rPr sz="1050" b="0">
+                          <a:solidFill>
+                            <a:srgbClr val="263442"/>
+                          </a:solidFill>
+                          <a:latin typeface="Calibri"/>
+                        </a:rPr>
+                        <a:t>andinalog_iot_telemetry_silver.csv</a:t>
+                      </a:r>
+                    </a:p>
+                  </a:txBody>
+                  <a:tcPr anchor="ctr" marL="54864" marR="54864" marT="32004" marB="32004">
+                    <a:lnL w="9525" cap="flat" cmpd="sng" algn="ctr">
+                      <a:solidFill>
+                        <a:srgbClr val="C9D3DD"/>
+                      </a:solidFill>
+                      <a:prstDash val="solid"/>
+                    </a:lnL>
+                    <a:lnR w="9525" cap="flat" cmpd="sng" algn="ctr">
+                      <a:solidFill>
+                        <a:srgbClr val="C9D3DD"/>
+                      </a:solidFill>
+                      <a:prstDash val="solid"/>
+                    </a:lnR>
+                    <a:lnT w="9525" cap="flat" cmpd="sng" algn="ctr">
+                      <a:solidFill>
+                        <a:srgbClr val="C9D3DD"/>
+                      </a:solidFill>
+                      <a:prstDash val="solid"/>
+                    </a:lnT>
+                    <a:lnB w="9525" cap="flat" cmpd="sng" algn="ctr">
+                      <a:solidFill>
+                        <a:srgbClr val="C9D3DD"/>
+                      </a:solidFill>
+                      <a:prstDash val="solid"/>
+                    </a:lnB>
+                    <a:solidFill>
+                      <a:srgbClr val="FFFFFF"/>
+                    </a:solidFill>
+                  </a:tcPr>
+                </a:tc>
+                <a:tc>
+                  <a:txBody>
+                    <a:bodyPr wrap="square"/>
+                    <a:lstStyle/>
+                    <a:p>
+                      <a:pPr algn="l">
+                        <a:lnSpc>
+                          <a:spcPct val="100000"/>
+                        </a:lnSpc>
+                        <a:spcBef>
+                          <a:spcPts val="0"/>
+                        </a:spcBef>
+                        <a:spcAft>
+                          <a:spcPts val="0"/>
+                        </a:spcAft>
+                      </a:pPr>
+                      <a:r>
+                        <a:rPr sz="1050" b="0">
+                          <a:solidFill>
+                            <a:srgbClr val="263442"/>
+                          </a:solidFill>
+                          <a:latin typeface="Calibri"/>
+                        </a:rPr>
+                        <a:t>Una lectura dentro de un viaje</a:t>
+                      </a:r>
+                    </a:p>
+                  </a:txBody>
+                  <a:tcPr anchor="ctr" marL="54864" marR="54864" marT="32004" marB="32004">
+                    <a:lnL w="9525" cap="flat" cmpd="sng" algn="ctr">
+                      <a:solidFill>
+                        <a:srgbClr val="C9D3DD"/>
+                      </a:solidFill>
+                      <a:prstDash val="solid"/>
+                    </a:lnL>
+                    <a:lnR w="9525" cap="flat" cmpd="sng" algn="ctr">
+                      <a:solidFill>
+                        <a:srgbClr val="C9D3DD"/>
+                      </a:solidFill>
+                      <a:prstDash val="solid"/>
+                    </a:lnR>
+                    <a:lnT w="9525" cap="flat" cmpd="sng" algn="ctr">
+                      <a:solidFill>
+                        <a:srgbClr val="C9D3DD"/>
+                      </a:solidFill>
+                      <a:prstDash val="solid"/>
+                    </a:lnT>
+                    <a:lnB w="9525" cap="flat" cmpd="sng" algn="ctr">
+                      <a:solidFill>
+                        <a:srgbClr val="C9D3DD"/>
+                      </a:solidFill>
+                      <a:prstDash val="solid"/>
+                    </a:lnB>
+                    <a:solidFill>
+                      <a:srgbClr val="FFFFFF"/>
+                    </a:solidFill>
+                  </a:tcPr>
+                </a:tc>
+                <a:tc>
+                  <a:txBody>
+                    <a:bodyPr wrap="square"/>
+                    <a:lstStyle/>
+                    <a:p>
+                      <a:pPr algn="l">
+                        <a:lnSpc>
+                          <a:spcPct val="100000"/>
+                        </a:lnSpc>
+                        <a:spcBef>
+                          <a:spcPts val="0"/>
+                        </a:spcBef>
+                        <a:spcAft>
+                          <a:spcPts val="0"/>
+                        </a:spcAft>
+                      </a:pPr>
+                      <a:r>
+                        <a:rPr sz="1050" b="0">
+                          <a:solidFill>
+                            <a:srgbClr val="263442"/>
+                          </a:solidFill>
+                          <a:latin typeface="Calibri"/>
+                        </a:rPr>
+                        <a:t>viaje_id + minutos_desde_despacho</a:t>
+                      </a:r>
+                    </a:p>
+                  </a:txBody>
+                  <a:tcPr anchor="ctr" marL="54864" marR="54864" marT="32004" marB="32004">
+                    <a:lnL w="9525" cap="flat" cmpd="sng" algn="ctr">
+                      <a:solidFill>
+                        <a:srgbClr val="C9D3DD"/>
+                      </a:solidFill>
+                      <a:prstDash val="solid"/>
+                    </a:lnL>
+                    <a:lnR w="9525" cap="flat" cmpd="sng" algn="ctr">
+                      <a:solidFill>
+                        <a:srgbClr val="C9D3DD"/>
+                      </a:solidFill>
+                      <a:prstDash val="solid"/>
+                    </a:lnR>
+                    <a:lnT w="9525" cap="flat" cmpd="sng" algn="ctr">
+                      <a:solidFill>
+                        <a:srgbClr val="C9D3DD"/>
+                      </a:solidFill>
+                      <a:prstDash val="solid"/>
+                    </a:lnT>
+                    <a:lnB w="9525" cap="flat" cmpd="sng" algn="ctr">
+                      <a:solidFill>
+                        <a:srgbClr val="C9D3DD"/>
+                      </a:solidFill>
+                      <a:prstDash val="solid"/>
+                    </a:lnB>
+                    <a:solidFill>
+                      <a:srgbClr val="FFFFFF"/>
+                    </a:solidFill>
+                  </a:tcPr>
+                </a:tc>
+                <a:tc>
+                  <a:txBody>
+                    <a:bodyPr wrap="square"/>
+                    <a:lstStyle/>
+                    <a:p>
+                      <a:pPr algn="l">
+                        <a:lnSpc>
+                          <a:spcPct val="100000"/>
+                        </a:lnSpc>
+                        <a:spcBef>
+                          <a:spcPts val="0"/>
+                        </a:spcBef>
+                        <a:spcAft>
+                          <a:spcPts val="0"/>
+                        </a:spcAft>
+                      </a:pPr>
+                      <a:r>
+                        <a:rPr sz="1050" b="0">
+                          <a:solidFill>
+                            <a:srgbClr val="263442"/>
+                          </a:solidFill>
+                          <a:latin typeface="Calibri"/>
+                        </a:rPr>
+                        <a:t>Observación cada 30 min; actualización por acordar</a:t>
+                      </a:r>
+                    </a:p>
+                  </a:txBody>
+                  <a:tcPr anchor="ctr" marL="54864" marR="54864" marT="32004" marB="32004">
+                    <a:lnL w="9525" cap="flat" cmpd="sng" algn="ctr">
+                      <a:solidFill>
+                        <a:srgbClr val="C9D3DD"/>
+                      </a:solidFill>
+                      <a:prstDash val="solid"/>
+                    </a:lnL>
+                    <a:lnR w="9525" cap="flat" cmpd="sng" algn="ctr">
+                      <a:solidFill>
+                        <a:srgbClr val="C9D3DD"/>
+                      </a:solidFill>
+                      <a:prstDash val="solid"/>
+                    </a:lnR>
+                    <a:lnT w="9525" cap="flat" cmpd="sng" algn="ctr">
+                      <a:solidFill>
+                        <a:srgbClr val="C9D3DD"/>
+                      </a:solidFill>
+                      <a:prstDash val="solid"/>
+                    </a:lnT>
+                    <a:lnB w="9525" cap="flat" cmpd="sng" algn="ctr">
+                      <a:solidFill>
+                        <a:srgbClr val="C9D3DD"/>
+                      </a:solidFill>
+                      <a:prstDash val="solid"/>
+                    </a:lnB>
+                    <a:solidFill>
+                      <a:srgbClr val="FFFFFF"/>
+                    </a:solidFill>
+                  </a:tcPr>
+                </a:tc>
+                <a:tc>
+                  <a:txBody>
+                    <a:bodyPr wrap="square"/>
+                    <a:lstStyle/>
+                    <a:p>
+                      <a:pPr algn="l">
+                        <a:lnSpc>
+                          <a:spcPct val="100000"/>
+                        </a:lnSpc>
+                        <a:spcBef>
+                          <a:spcPts val="0"/>
+                        </a:spcBef>
+                        <a:spcAft>
+                          <a:spcPts val="0"/>
+                        </a:spcAft>
+                      </a:pPr>
+                      <a:r>
+                        <a:rPr sz="1050" b="0">
+                          <a:solidFill>
+                            <a:srgbClr val="263442"/>
+                          </a:solidFill>
+                          <a:latin typeface="Calibri"/>
+                        </a:rPr>
+                        <a:t>Por acordar; revisión Grupo 06</a:t>
+                      </a:r>
+                    </a:p>
+                  </a:txBody>
+                  <a:tcPr anchor="ctr" marL="54864" marR="54864" marT="32004" marB="32004">
+                    <a:lnL w="9525" cap="flat" cmpd="sng" algn="ctr">
+                      <a:solidFill>
+                        <a:srgbClr val="C9D3DD"/>
+                      </a:solidFill>
+                      <a:prstDash val="solid"/>
+                    </a:lnL>
+                    <a:lnR w="9525" cap="flat" cmpd="sng" algn="ctr">
+                      <a:solidFill>
+                        <a:srgbClr val="C9D3DD"/>
+                      </a:solidFill>
+                      <a:prstDash val="solid"/>
+                    </a:lnR>
+                    <a:lnT w="9525" cap="flat" cmpd="sng" algn="ctr">
+                      <a:solidFill>
+                        <a:srgbClr val="C9D3DD"/>
+                      </a:solidFill>
+                      <a:prstDash val="solid"/>
+                    </a:lnT>
+                    <a:lnB w="9525" cap="flat" cmpd="sng" algn="ctr">
+                      <a:solidFill>
+                        <a:srgbClr val="C9D3DD"/>
+                      </a:solidFill>
+                      <a:prstDash val="solid"/>
+                    </a:lnB>
+                    <a:solidFill>
+                      <a:srgbClr val="FFFFFF"/>
+                    </a:solidFill>
+                  </a:tcPr>
+                </a:tc>
+                <a:tc>
+                  <a:txBody>
+                    <a:bodyPr wrap="square"/>
+                    <a:lstStyle/>
+                    <a:p>
+                      <a:pPr algn="l">
+                        <a:lnSpc>
+                          <a:spcPct val="100000"/>
+                        </a:lnSpc>
+                        <a:spcBef>
+                          <a:spcPts val="0"/>
+                        </a:spcBef>
+                        <a:spcAft>
+                          <a:spcPts val="0"/>
+                        </a:spcAft>
+                      </a:pPr>
+                      <a:r>
+                        <a:rPr sz="1050" b="0">
+                          <a:solidFill>
+                            <a:srgbClr val="263442"/>
+                          </a:solidFill>
+                          <a:latin typeface="Calibri"/>
+                        </a:rPr>
+                        <a:t>Interpretar el centro del camión como centro real del viaje</a:t>
+                      </a:r>
+                    </a:p>
+                  </a:txBody>
+                  <a:tcPr anchor="ctr" marL="54864" marR="54864" marT="32004" marB="32004">
+                    <a:lnL w="9525" cap="flat" cmpd="sng" algn="ctr">
+                      <a:solidFill>
+                        <a:srgbClr val="C9D3DD"/>
+                      </a:solidFill>
+                      <a:prstDash val="solid"/>
+                    </a:lnL>
+                    <a:lnR w="9525" cap="flat" cmpd="sng" algn="ctr">
+                      <a:solidFill>
+                        <a:srgbClr val="C9D3DD"/>
+                      </a:solidFill>
+                      <a:prstDash val="solid"/>
+                    </a:lnR>
+                    <a:lnT w="9525" cap="flat" cmpd="sng" algn="ctr">
+                      <a:solidFill>
+                        <a:srgbClr val="C9D3DD"/>
+                      </a:solidFill>
+                      <a:prstDash val="solid"/>
+                    </a:lnT>
+                    <a:lnB w="9525" cap="flat" cmpd="sng" algn="ctr">
+                      <a:solidFill>
+                        <a:srgbClr val="C9D3DD"/>
+                      </a:solidFill>
+                      <a:prstDash val="solid"/>
+                    </a:lnB>
+                    <a:solidFill>
+                      <a:srgbClr val="FFFFFF"/>
+                    </a:solidFill>
+                  </a:tcPr>
+                </a:tc>
+                <a:tc>
+                  <a:txBody>
+                    <a:bodyPr wrap="square"/>
+                    <a:lstStyle/>
+                    <a:p>
+                      <a:pPr algn="l">
+                        <a:lnSpc>
+                          <a:spcPct val="100000"/>
+                        </a:lnSpc>
+                        <a:spcBef>
+                          <a:spcPts val="0"/>
+                        </a:spcBef>
+                        <a:spcAft>
+                          <a:spcPts val="0"/>
+                        </a:spcAft>
+                      </a:pPr>
+                      <a:r>
+                        <a:rPr sz="1050" b="0">
+                          <a:solidFill>
+                            <a:srgbClr val="263442"/>
+                          </a:solidFill>
+                          <a:latin typeface="Calibri"/>
+                        </a:rPr>
+                        <a:t>Documentar el límite y no usar el centro base como ruta; control de clave compuesta</a:t>
+                      </a:r>
+                    </a:p>
+                  </a:txBody>
+                  <a:tcPr anchor="ctr" marL="54864" marR="54864" marT="32004" marB="32004">
+                    <a:lnL w="9525" cap="flat" cmpd="sng" algn="ctr">
+                      <a:solidFill>
+                        <a:srgbClr val="C9D3DD"/>
+                      </a:solidFill>
+                      <a:prstDash val="solid"/>
+                    </a:lnL>
+                    <a:lnR w="9525" cap="flat" cmpd="sng" algn="ctr">
+                      <a:solidFill>
+                        <a:srgbClr val="C9D3DD"/>
+                      </a:solidFill>
+                      <a:prstDash val="solid"/>
+                    </a:lnR>
+                    <a:lnT w="9525" cap="flat" cmpd="sng" algn="ctr">
+                      <a:solidFill>
+                        <a:srgbClr val="C9D3DD"/>
+                      </a:solidFill>
+                      <a:prstDash val="solid"/>
+                    </a:lnT>
+                    <a:lnB w="9525" cap="flat" cmpd="sng" algn="ctr">
+                      <a:solidFill>
+                        <a:srgbClr val="C9D3DD"/>
+                      </a:solidFill>
+                      <a:prstDash val="solid"/>
+                    </a:lnB>
+                    <a:solidFill>
+                      <a:srgbClr val="FFFFFF"/>
+                    </a:solidFill>
+                  </a:tcPr>
+                </a:tc>
+              </a:tr>
+              <a:tr h="1508760">
+                <a:tc>
+                  <a:txBody>
+                    <a:bodyPr wrap="square"/>
+                    <a:lstStyle/>
+                    <a:p>
+                      <a:pPr algn="l">
+                        <a:lnSpc>
+                          <a:spcPct val="100000"/>
+                        </a:lnSpc>
+                        <a:spcBef>
+                          <a:spcPts val="0"/>
+                        </a:spcBef>
+                        <a:spcAft>
+                          <a:spcPts val="0"/>
+                        </a:spcAft>
+                      </a:pPr>
+                      <a:r>
+                        <a:rPr sz="1050" b="0">
+                          <a:solidFill>
+                            <a:srgbClr val="263442"/>
+                          </a:solidFill>
+                          <a:latin typeface="Calibri"/>
+                        </a:rPr>
+                        <a:t>andinalog_productos_silver.csv</a:t>
+                      </a:r>
+                    </a:p>
+                  </a:txBody>
+                  <a:tcPr anchor="ctr" marL="54864" marR="54864" marT="32004" marB="32004">
+                    <a:lnL w="9525" cap="flat" cmpd="sng" algn="ctr">
+                      <a:solidFill>
+                        <a:srgbClr val="C9D3DD"/>
+                      </a:solidFill>
+                      <a:prstDash val="solid"/>
+                    </a:lnL>
+                    <a:lnR w="9525" cap="flat" cmpd="sng" algn="ctr">
+                      <a:solidFill>
+                        <a:srgbClr val="C9D3DD"/>
+                      </a:solidFill>
+                      <a:prstDash val="solid"/>
+                    </a:lnR>
+                    <a:lnT w="9525" cap="flat" cmpd="sng" algn="ctr">
+                      <a:solidFill>
+                        <a:srgbClr val="C9D3DD"/>
+                      </a:solidFill>
+                      <a:prstDash val="solid"/>
+                    </a:lnT>
+                    <a:lnB w="9525" cap="flat" cmpd="sng" algn="ctr">
+                      <a:solidFill>
+                        <a:srgbClr val="C9D3DD"/>
+                      </a:solidFill>
+                      <a:prstDash val="solid"/>
+                    </a:lnB>
+                    <a:solidFill>
+                      <a:srgbClr val="F2F6F9"/>
+                    </a:solidFill>
+                  </a:tcPr>
+                </a:tc>
+                <a:tc>
+                  <a:txBody>
+                    <a:bodyPr wrap="square"/>
+                    <a:lstStyle/>
+                    <a:p>
+                      <a:pPr algn="l">
+                        <a:lnSpc>
+                          <a:spcPct val="100000"/>
+                        </a:lnSpc>
+                        <a:spcBef>
+                          <a:spcPts val="0"/>
+                        </a:spcBef>
+                        <a:spcAft>
+                          <a:spcPts val="0"/>
+                        </a:spcAft>
+                      </a:pPr>
+                      <a:r>
+                        <a:rPr sz="1050" b="0">
+                          <a:solidFill>
+                            <a:srgbClr val="263442"/>
+                          </a:solidFill>
+                          <a:latin typeface="Calibri"/>
+                        </a:rPr>
+                        <a:t>Un producto</a:t>
+                      </a:r>
+                    </a:p>
+                  </a:txBody>
+                  <a:tcPr anchor="ctr" marL="54864" marR="54864" marT="32004" marB="32004">
+                    <a:lnL w="9525" cap="flat" cmpd="sng" algn="ctr">
+                      <a:solidFill>
+                        <a:srgbClr val="C9D3DD"/>
+                      </a:solidFill>
+                      <a:prstDash val="solid"/>
+                    </a:lnL>
+                    <a:lnR w="9525" cap="flat" cmpd="sng" algn="ctr">
+                      <a:solidFill>
+                        <a:srgbClr val="C9D3DD"/>
+                      </a:solidFill>
+                      <a:prstDash val="solid"/>
+                    </a:lnR>
+                    <a:lnT w="9525" cap="flat" cmpd="sng" algn="ctr">
+                      <a:solidFill>
+                        <a:srgbClr val="C9D3DD"/>
+                      </a:solidFill>
+                      <a:prstDash val="solid"/>
+                    </a:lnT>
+                    <a:lnB w="9525" cap="flat" cmpd="sng" algn="ctr">
+                      <a:solidFill>
+                        <a:srgbClr val="C9D3DD"/>
+                      </a:solidFill>
+                      <a:prstDash val="solid"/>
+                    </a:lnB>
+                    <a:solidFill>
+                      <a:srgbClr val="F2F6F9"/>
+                    </a:solidFill>
+                  </a:tcPr>
+                </a:tc>
+                <a:tc>
+                  <a:txBody>
+                    <a:bodyPr wrap="square"/>
+                    <a:lstStyle/>
+                    <a:p>
+                      <a:pPr algn="l">
+                        <a:lnSpc>
+                          <a:spcPct val="100000"/>
+                        </a:lnSpc>
+                        <a:spcBef>
+                          <a:spcPts val="0"/>
+                        </a:spcBef>
+                        <a:spcAft>
+                          <a:spcPts val="0"/>
+                        </a:spcAft>
+                      </a:pPr>
+                      <a:r>
+                        <a:rPr sz="1050" b="0">
+                          <a:solidFill>
+                            <a:srgbClr val="263442"/>
+                          </a:solidFill>
+                          <a:latin typeface="Calibri"/>
+                        </a:rPr>
+                        <a:t>producto_id</a:t>
+                      </a:r>
+                    </a:p>
+                  </a:txBody>
+                  <a:tcPr anchor="ctr" marL="54864" marR="54864" marT="32004" marB="32004">
+                    <a:lnL w="9525" cap="flat" cmpd="sng" algn="ctr">
+                      <a:solidFill>
+                        <a:srgbClr val="C9D3DD"/>
+                      </a:solidFill>
+                      <a:prstDash val="solid"/>
+                    </a:lnL>
+                    <a:lnR w="9525" cap="flat" cmpd="sng" algn="ctr">
+                      <a:solidFill>
+                        <a:srgbClr val="C9D3DD"/>
+                      </a:solidFill>
+                      <a:prstDash val="solid"/>
+                    </a:lnR>
+                    <a:lnT w="9525" cap="flat" cmpd="sng" algn="ctr">
+                      <a:solidFill>
+                        <a:srgbClr val="C9D3DD"/>
+                      </a:solidFill>
+                      <a:prstDash val="solid"/>
+                    </a:lnT>
+                    <a:lnB w="9525" cap="flat" cmpd="sng" algn="ctr">
+                      <a:solidFill>
+                        <a:srgbClr val="C9D3DD"/>
+                      </a:solidFill>
+                      <a:prstDash val="solid"/>
+                    </a:lnB>
+                    <a:solidFill>
+                      <a:srgbClr val="F2F6F9"/>
+                    </a:solidFill>
+                  </a:tcPr>
+                </a:tc>
+                <a:tc>
+                  <a:txBody>
+                    <a:bodyPr wrap="square"/>
+                    <a:lstStyle/>
+                    <a:p>
+                      <a:pPr algn="l">
+                        <a:lnSpc>
+                          <a:spcPct val="100000"/>
+                        </a:lnSpc>
+                        <a:spcBef>
+                          <a:spcPts val="0"/>
+                        </a:spcBef>
+                        <a:spcAft>
+                          <a:spcPts val="0"/>
+                        </a:spcAft>
+                      </a:pPr>
+                      <a:r>
+                        <a:rPr sz="1050" b="0">
+                          <a:solidFill>
+                            <a:srgbClr val="263442"/>
+                          </a:solidFill>
+                          <a:latin typeface="Calibri"/>
+                        </a:rPr>
+                        <a:t>Catálogo; actualización por acordar</a:t>
+                      </a:r>
+                    </a:p>
+                  </a:txBody>
+                  <a:tcPr anchor="ctr" marL="54864" marR="54864" marT="32004" marB="32004">
+                    <a:lnL w="9525" cap="flat" cmpd="sng" algn="ctr">
+                      <a:solidFill>
+                        <a:srgbClr val="C9D3DD"/>
+                      </a:solidFill>
+                      <a:prstDash val="solid"/>
+                    </a:lnL>
+                    <a:lnR w="9525" cap="flat" cmpd="sng" algn="ctr">
+                      <a:solidFill>
+                        <a:srgbClr val="C9D3DD"/>
+                      </a:solidFill>
+                      <a:prstDash val="solid"/>
+                    </a:lnR>
+                    <a:lnT w="9525" cap="flat" cmpd="sng" algn="ctr">
+                      <a:solidFill>
+                        <a:srgbClr val="C9D3DD"/>
+                      </a:solidFill>
+                      <a:prstDash val="solid"/>
+                    </a:lnT>
+                    <a:lnB w="9525" cap="flat" cmpd="sng" algn="ctr">
+                      <a:solidFill>
+                        <a:srgbClr val="C9D3DD"/>
+                      </a:solidFill>
+                      <a:prstDash val="solid"/>
+                    </a:lnB>
+                    <a:solidFill>
+                      <a:srgbClr val="F2F6F9"/>
+                    </a:solidFill>
+                  </a:tcPr>
+                </a:tc>
+                <a:tc>
+                  <a:txBody>
+                    <a:bodyPr wrap="square"/>
+                    <a:lstStyle/>
+                    <a:p>
+                      <a:pPr algn="l">
+                        <a:lnSpc>
+                          <a:spcPct val="100000"/>
+                        </a:lnSpc>
+                        <a:spcBef>
+                          <a:spcPts val="0"/>
+                        </a:spcBef>
+                        <a:spcAft>
+                          <a:spcPts val="0"/>
+                        </a:spcAft>
+                      </a:pPr>
+                      <a:r>
+                        <a:rPr sz="1050" b="0">
+                          <a:solidFill>
+                            <a:srgbClr val="263442"/>
+                          </a:solidFill>
+                          <a:latin typeface="Calibri"/>
+                        </a:rPr>
+                        <a:t>Por acordar; revisión Grupo 06</a:t>
+                      </a:r>
+                    </a:p>
+                  </a:txBody>
+                  <a:tcPr anchor="ctr" marL="54864" marR="54864" marT="32004" marB="32004">
+                    <a:lnL w="9525" cap="flat" cmpd="sng" algn="ctr">
+                      <a:solidFill>
+                        <a:srgbClr val="C9D3DD"/>
+                      </a:solidFill>
+                      <a:prstDash val="solid"/>
+                    </a:lnL>
+                    <a:lnR w="9525" cap="flat" cmpd="sng" algn="ctr">
+                      <a:solidFill>
+                        <a:srgbClr val="C9D3DD"/>
+                      </a:solidFill>
+                      <a:prstDash val="solid"/>
+                    </a:lnR>
+                    <a:lnT w="9525" cap="flat" cmpd="sng" algn="ctr">
+                      <a:solidFill>
+                        <a:srgbClr val="C9D3DD"/>
+                      </a:solidFill>
+                      <a:prstDash val="solid"/>
+                    </a:lnT>
+                    <a:lnB w="9525" cap="flat" cmpd="sng" algn="ctr">
+                      <a:solidFill>
+                        <a:srgbClr val="C9D3DD"/>
+                      </a:solidFill>
+                      <a:prstDash val="solid"/>
+                    </a:lnB>
+                    <a:solidFill>
+                      <a:srgbClr val="F2F6F9"/>
+                    </a:solidFill>
+                  </a:tcPr>
+                </a:tc>
+                <a:tc>
+                  <a:txBody>
+                    <a:bodyPr wrap="square"/>
+                    <a:lstStyle/>
+                    <a:p>
+                      <a:pPr algn="l">
+                        <a:lnSpc>
+                          <a:spcPct val="100000"/>
+                        </a:lnSpc>
+                        <a:spcBef>
+                          <a:spcPts val="0"/>
+                        </a:spcBef>
+                        <a:spcAft>
+                          <a:spcPts val="0"/>
+                        </a:spcAft>
+                      </a:pPr>
+                      <a:r>
+                        <a:rPr sz="1050" b="0">
+                          <a:solidFill>
+                            <a:srgbClr val="263442"/>
+                          </a:solidFill>
+                          <a:latin typeface="Calibri"/>
+                        </a:rPr>
+                        <a:t>Extrapolar KPI térmicos a todo el catálogo</a:t>
+                      </a:r>
+                    </a:p>
+                  </a:txBody>
+                  <a:tcPr anchor="ctr" marL="54864" marR="54864" marT="32004" marB="32004">
+                    <a:lnL w="9525" cap="flat" cmpd="sng" algn="ctr">
+                      <a:solidFill>
+                        <a:srgbClr val="C9D3DD"/>
+                      </a:solidFill>
+                      <a:prstDash val="solid"/>
+                    </a:lnL>
+                    <a:lnR w="9525" cap="flat" cmpd="sng" algn="ctr">
+                      <a:solidFill>
+                        <a:srgbClr val="C9D3DD"/>
+                      </a:solidFill>
+                      <a:prstDash val="solid"/>
+                    </a:lnR>
+                    <a:lnT w="9525" cap="flat" cmpd="sng" algn="ctr">
+                      <a:solidFill>
+                        <a:srgbClr val="C9D3DD"/>
+                      </a:solidFill>
+                      <a:prstDash val="solid"/>
+                    </a:lnT>
+                    <a:lnB w="9525" cap="flat" cmpd="sng" algn="ctr">
+                      <a:solidFill>
+                        <a:srgbClr val="C9D3DD"/>
+                      </a:solidFill>
+                      <a:prstDash val="solid"/>
+                    </a:lnB>
+                    <a:solidFill>
+                      <a:srgbClr val="F2F6F9"/>
+                    </a:solidFill>
+                  </a:tcPr>
+                </a:tc>
+                <a:tc>
+                  <a:txBody>
+                    <a:bodyPr wrap="square"/>
+                    <a:lstStyle/>
+                    <a:p>
+                      <a:pPr algn="l">
+                        <a:lnSpc>
+                          <a:spcPct val="100000"/>
+                        </a:lnSpc>
+                        <a:spcBef>
+                          <a:spcPts val="0"/>
+                        </a:spcBef>
+                        <a:spcAft>
+                          <a:spcPts val="0"/>
+                        </a:spcAft>
+                      </a:pPr>
+                      <a:r>
+                        <a:rPr sz="1050" b="0">
+                          <a:solidFill>
+                            <a:srgbClr val="263442"/>
+                          </a:solidFill>
+                          <a:latin typeface="Calibri"/>
+                        </a:rPr>
+                        <a:t>Registrar cobertura 70 de 120 en telemetría</a:t>
+                      </a:r>
+                    </a:p>
+                  </a:txBody>
+                  <a:tcPr anchor="ctr" marL="54864" marR="54864" marT="32004" marB="32004">
+                    <a:lnL w="9525" cap="flat" cmpd="sng" algn="ctr">
+                      <a:solidFill>
+                        <a:srgbClr val="C9D3DD"/>
+                      </a:solidFill>
+                      <a:prstDash val="solid"/>
+                    </a:lnL>
+                    <a:lnR w="9525" cap="flat" cmpd="sng" algn="ctr">
+                      <a:solidFill>
+                        <a:srgbClr val="C9D3DD"/>
+                      </a:solidFill>
+                      <a:prstDash val="solid"/>
+                    </a:lnR>
+                    <a:lnT w="9525" cap="flat" cmpd="sng" algn="ctr">
+                      <a:solidFill>
+                        <a:srgbClr val="C9D3DD"/>
+                      </a:solidFill>
+                      <a:prstDash val="solid"/>
+                    </a:lnT>
+                    <a:lnB w="9525" cap="flat" cmpd="sng" algn="ctr">
+                      <a:solidFill>
+                        <a:srgbClr val="C9D3DD"/>
+                      </a:solidFill>
+                      <a:prstDash val="solid"/>
+                    </a:lnB>
+                    <a:solidFill>
+                      <a:srgbClr val="F2F6F9"/>
+                    </a:solidFill>
+                  </a:tcPr>
+                </a:tc>
+              </a:tr>
+              <a:tr h="1508760">
+                <a:tc>
+                  <a:txBody>
+                    <a:bodyPr wrap="square"/>
+                    <a:lstStyle/>
+                    <a:p>
+                      <a:pPr algn="l">
+                        <a:lnSpc>
+                          <a:spcPct val="100000"/>
+                        </a:lnSpc>
+                        <a:spcBef>
+                          <a:spcPts val="0"/>
+                        </a:spcBef>
+                        <a:spcAft>
+                          <a:spcPts val="0"/>
+                        </a:spcAft>
+                      </a:pPr>
+                      <a:r>
+                        <a:rPr sz="1050" b="0">
+                          <a:solidFill>
+                            <a:srgbClr val="263442"/>
+                          </a:solidFill>
+                          <a:latin typeface="Calibri"/>
+                        </a:rPr>
+                        <a:t>andinalog_flota_silver.csv</a:t>
+                      </a:r>
+                    </a:p>
+                  </a:txBody>
+                  <a:tcPr anchor="ctr" marL="54864" marR="54864" marT="32004" marB="32004">
+                    <a:lnL w="9525" cap="flat" cmpd="sng" algn="ctr">
+                      <a:solidFill>
+                        <a:srgbClr val="C9D3DD"/>
+                      </a:solidFill>
+                      <a:prstDash val="solid"/>
+                    </a:lnL>
+                    <a:lnR w="9525" cap="flat" cmpd="sng" algn="ctr">
+                      <a:solidFill>
+                        <a:srgbClr val="C9D3DD"/>
+                      </a:solidFill>
+                      <a:prstDash val="solid"/>
+                    </a:lnR>
+                    <a:lnT w="9525" cap="flat" cmpd="sng" algn="ctr">
+                      <a:solidFill>
+                        <a:srgbClr val="C9D3DD"/>
+                      </a:solidFill>
+                      <a:prstDash val="solid"/>
+                    </a:lnT>
+                    <a:lnB w="9525" cap="flat" cmpd="sng" algn="ctr">
+                      <a:solidFill>
+                        <a:srgbClr val="C9D3DD"/>
+                      </a:solidFill>
+                      <a:prstDash val="solid"/>
+                    </a:lnB>
+                    <a:solidFill>
+                      <a:srgbClr val="FFFFFF"/>
+                    </a:solidFill>
+                  </a:tcPr>
+                </a:tc>
+                <a:tc>
+                  <a:txBody>
+                    <a:bodyPr wrap="square"/>
+                    <a:lstStyle/>
+                    <a:p>
+                      <a:pPr algn="l">
+                        <a:lnSpc>
+                          <a:spcPct val="100000"/>
+                        </a:lnSpc>
+                        <a:spcBef>
+                          <a:spcPts val="0"/>
+                        </a:spcBef>
+                        <a:spcAft>
+                          <a:spcPts val="0"/>
+                        </a:spcAft>
+                      </a:pPr>
+                      <a:r>
+                        <a:rPr sz="1050" b="0">
+                          <a:solidFill>
+                            <a:srgbClr val="263442"/>
+                          </a:solidFill>
+                          <a:latin typeface="Calibri"/>
+                        </a:rPr>
+                        <a:t>Un camión</a:t>
+                      </a:r>
+                    </a:p>
+                  </a:txBody>
+                  <a:tcPr anchor="ctr" marL="54864" marR="54864" marT="32004" marB="32004">
+                    <a:lnL w="9525" cap="flat" cmpd="sng" algn="ctr">
+                      <a:solidFill>
+                        <a:srgbClr val="C9D3DD"/>
+                      </a:solidFill>
+                      <a:prstDash val="solid"/>
+                    </a:lnL>
+                    <a:lnR w="9525" cap="flat" cmpd="sng" algn="ctr">
+                      <a:solidFill>
+                        <a:srgbClr val="C9D3DD"/>
+                      </a:solidFill>
+                      <a:prstDash val="solid"/>
+                    </a:lnR>
+                    <a:lnT w="9525" cap="flat" cmpd="sng" algn="ctr">
+                      <a:solidFill>
+                        <a:srgbClr val="C9D3DD"/>
+                      </a:solidFill>
+                      <a:prstDash val="solid"/>
+                    </a:lnT>
+                    <a:lnB w="9525" cap="flat" cmpd="sng" algn="ctr">
+                      <a:solidFill>
+                        <a:srgbClr val="C9D3DD"/>
+                      </a:solidFill>
+                      <a:prstDash val="solid"/>
+                    </a:lnB>
+                    <a:solidFill>
+                      <a:srgbClr val="FFFFFF"/>
+                    </a:solidFill>
+                  </a:tcPr>
+                </a:tc>
+                <a:tc>
+                  <a:txBody>
+                    <a:bodyPr wrap="square"/>
+                    <a:lstStyle/>
+                    <a:p>
+                      <a:pPr algn="l">
+                        <a:lnSpc>
+                          <a:spcPct val="100000"/>
+                        </a:lnSpc>
+                        <a:spcBef>
+                          <a:spcPts val="0"/>
+                        </a:spcBef>
+                        <a:spcAft>
+                          <a:spcPts val="0"/>
+                        </a:spcAft>
+                      </a:pPr>
+                      <a:r>
+                        <a:rPr sz="1050" b="0">
+                          <a:solidFill>
+                            <a:srgbClr val="263442"/>
+                          </a:solidFill>
+                          <a:latin typeface="Calibri"/>
+                        </a:rPr>
+                        <a:t>camion_id</a:t>
+                      </a:r>
+                    </a:p>
+                  </a:txBody>
+                  <a:tcPr anchor="ctr" marL="54864" marR="54864" marT="32004" marB="32004">
+                    <a:lnL w="9525" cap="flat" cmpd="sng" algn="ctr">
+                      <a:solidFill>
+                        <a:srgbClr val="C9D3DD"/>
+                      </a:solidFill>
+                      <a:prstDash val="solid"/>
+                    </a:lnL>
+                    <a:lnR w="9525" cap="flat" cmpd="sng" algn="ctr">
+                      <a:solidFill>
+                        <a:srgbClr val="C9D3DD"/>
+                      </a:solidFill>
+                      <a:prstDash val="solid"/>
+                    </a:lnR>
+                    <a:lnT w="9525" cap="flat" cmpd="sng" algn="ctr">
+                      <a:solidFill>
+                        <a:srgbClr val="C9D3DD"/>
+                      </a:solidFill>
+                      <a:prstDash val="solid"/>
+                    </a:lnT>
+                    <a:lnB w="9525" cap="flat" cmpd="sng" algn="ctr">
+                      <a:solidFill>
+                        <a:srgbClr val="C9D3DD"/>
+                      </a:solidFill>
+                      <a:prstDash val="solid"/>
+                    </a:lnB>
+                    <a:solidFill>
+                      <a:srgbClr val="FFFFFF"/>
+                    </a:solidFill>
+                  </a:tcPr>
+                </a:tc>
+                <a:tc>
+                  <a:txBody>
+                    <a:bodyPr wrap="square"/>
+                    <a:lstStyle/>
+                    <a:p>
+                      <a:pPr algn="l">
+                        <a:lnSpc>
+                          <a:spcPct val="100000"/>
+                        </a:lnSpc>
+                        <a:spcBef>
+                          <a:spcPts val="0"/>
+                        </a:spcBef>
+                        <a:spcAft>
+                          <a:spcPts val="0"/>
+                        </a:spcAft>
+                      </a:pPr>
+                      <a:r>
+                        <a:rPr sz="1050" b="0">
+                          <a:solidFill>
+                            <a:srgbClr val="263442"/>
+                          </a:solidFill>
+                          <a:latin typeface="Calibri"/>
+                        </a:rPr>
+                        <a:t>Catálogo; actualización por acordar</a:t>
+                      </a:r>
+                    </a:p>
+                  </a:txBody>
+                  <a:tcPr anchor="ctr" marL="54864" marR="54864" marT="32004" marB="32004">
+                    <a:lnL w="9525" cap="flat" cmpd="sng" algn="ctr">
+                      <a:solidFill>
+                        <a:srgbClr val="C9D3DD"/>
+                      </a:solidFill>
+                      <a:prstDash val="solid"/>
+                    </a:lnL>
+                    <a:lnR w="9525" cap="flat" cmpd="sng" algn="ctr">
+                      <a:solidFill>
+                        <a:srgbClr val="C9D3DD"/>
+                      </a:solidFill>
+                      <a:prstDash val="solid"/>
+                    </a:lnR>
+                    <a:lnT w="9525" cap="flat" cmpd="sng" algn="ctr">
+                      <a:solidFill>
+                        <a:srgbClr val="C9D3DD"/>
+                      </a:solidFill>
+                      <a:prstDash val="solid"/>
+                    </a:lnT>
+                    <a:lnB w="9525" cap="flat" cmpd="sng" algn="ctr">
+                      <a:solidFill>
+                        <a:srgbClr val="C9D3DD"/>
+                      </a:solidFill>
+                      <a:prstDash val="solid"/>
+                    </a:lnB>
+                    <a:solidFill>
+                      <a:srgbClr val="FFFFFF"/>
+                    </a:solidFill>
+                  </a:tcPr>
+                </a:tc>
+                <a:tc>
+                  <a:txBody>
+                    <a:bodyPr wrap="square"/>
+                    <a:lstStyle/>
+                    <a:p>
+                      <a:pPr algn="l">
+                        <a:lnSpc>
+                          <a:spcPct val="100000"/>
+                        </a:lnSpc>
+                        <a:spcBef>
+                          <a:spcPts val="0"/>
+                        </a:spcBef>
+                        <a:spcAft>
+                          <a:spcPts val="0"/>
+                        </a:spcAft>
+                      </a:pPr>
+                      <a:r>
+                        <a:rPr sz="1050" b="0">
+                          <a:solidFill>
+                            <a:srgbClr val="263442"/>
+                          </a:solidFill>
+                          <a:latin typeface="Calibri"/>
+                        </a:rPr>
+                        <a:t>Por acordar; revisión Grupo 06</a:t>
+                      </a:r>
+                    </a:p>
+                  </a:txBody>
+                  <a:tcPr anchor="ctr" marL="54864" marR="54864" marT="32004" marB="32004">
+                    <a:lnL w="9525" cap="flat" cmpd="sng" algn="ctr">
+                      <a:solidFill>
+                        <a:srgbClr val="C9D3DD"/>
+                      </a:solidFill>
+                      <a:prstDash val="solid"/>
+                    </a:lnL>
+                    <a:lnR w="9525" cap="flat" cmpd="sng" algn="ctr">
+                      <a:solidFill>
+                        <a:srgbClr val="C9D3DD"/>
+                      </a:solidFill>
+                      <a:prstDash val="solid"/>
+                    </a:lnR>
+                    <a:lnT w="9525" cap="flat" cmpd="sng" algn="ctr">
+                      <a:solidFill>
+                        <a:srgbClr val="C9D3DD"/>
+                      </a:solidFill>
+                      <a:prstDash val="solid"/>
+                    </a:lnT>
+                    <a:lnB w="9525" cap="flat" cmpd="sng" algn="ctr">
+                      <a:solidFill>
+                        <a:srgbClr val="C9D3DD"/>
+                      </a:solidFill>
+                      <a:prstDash val="solid"/>
+                    </a:lnB>
+                    <a:solidFill>
+                      <a:srgbClr val="FFFFFF"/>
+                    </a:solidFill>
+                  </a:tcPr>
+                </a:tc>
+                <a:tc>
+                  <a:txBody>
+                    <a:bodyPr wrap="square"/>
+                    <a:lstStyle/>
+                    <a:p>
+                      <a:pPr algn="l">
+                        <a:lnSpc>
+                          <a:spcPct val="100000"/>
+                        </a:lnSpc>
+                        <a:spcBef>
+                          <a:spcPts val="0"/>
+                        </a:spcBef>
+                        <a:spcAft>
+                          <a:spcPts val="0"/>
+                        </a:spcAft>
+                      </a:pPr>
+                      <a:r>
+                        <a:rPr sz="1050" b="0">
+                          <a:solidFill>
+                            <a:srgbClr val="263442"/>
+                          </a:solidFill>
+                          <a:latin typeface="Calibri"/>
+                        </a:rPr>
+                        <a:t>Usar centro_distribucion_base como centro operativo</a:t>
+                      </a:r>
+                    </a:p>
+                  </a:txBody>
+                  <a:tcPr anchor="ctr" marL="54864" marR="54864" marT="32004" marB="32004">
+                    <a:lnL w="9525" cap="flat" cmpd="sng" algn="ctr">
+                      <a:solidFill>
+                        <a:srgbClr val="C9D3DD"/>
+                      </a:solidFill>
+                      <a:prstDash val="solid"/>
+                    </a:lnL>
+                    <a:lnR w="9525" cap="flat" cmpd="sng" algn="ctr">
+                      <a:solidFill>
+                        <a:srgbClr val="C9D3DD"/>
+                      </a:solidFill>
+                      <a:prstDash val="solid"/>
+                    </a:lnR>
+                    <a:lnT w="9525" cap="flat" cmpd="sng" algn="ctr">
+                      <a:solidFill>
+                        <a:srgbClr val="C9D3DD"/>
+                      </a:solidFill>
+                      <a:prstDash val="solid"/>
+                    </a:lnT>
+                    <a:lnB w="9525" cap="flat" cmpd="sng" algn="ctr">
+                      <a:solidFill>
+                        <a:srgbClr val="C9D3DD"/>
+                      </a:solidFill>
+                      <a:prstDash val="solid"/>
+                    </a:lnB>
+                    <a:solidFill>
+                      <a:srgbClr val="FFFFFF"/>
+                    </a:solidFill>
+                  </a:tcPr>
+                </a:tc>
+                <a:tc>
+                  <a:txBody>
+                    <a:bodyPr wrap="square"/>
+                    <a:lstStyle/>
+                    <a:p>
+                      <a:pPr algn="l">
+                        <a:lnSpc>
+                          <a:spcPct val="100000"/>
+                        </a:lnSpc>
+                        <a:spcBef>
+                          <a:spcPts val="0"/>
+                        </a:spcBef>
+                        <a:spcAft>
+                          <a:spcPts val="0"/>
+                        </a:spcAft>
+                      </a:pPr>
+                      <a:r>
+                        <a:rPr sz="1050" b="0">
+                          <a:solidFill>
+                            <a:srgbClr val="263442"/>
+                          </a:solidFill>
+                          <a:latin typeface="Calibri"/>
+                        </a:rPr>
+                        <a:t>Mantener la distinción base/operativo y registrarla como pendiente</a:t>
+                      </a:r>
+                    </a:p>
+                  </a:txBody>
+                  <a:tcPr anchor="ctr" marL="54864" marR="54864" marT="32004" marB="32004">
+                    <a:lnL w="9525" cap="flat" cmpd="sng" algn="ctr">
+                      <a:solidFill>
+                        <a:srgbClr val="C9D3DD"/>
+                      </a:solidFill>
+                      <a:prstDash val="solid"/>
+                    </a:lnL>
+                    <a:lnR w="9525" cap="flat" cmpd="sng" algn="ctr">
+                      <a:solidFill>
+                        <a:srgbClr val="C9D3DD"/>
+                      </a:solidFill>
+                      <a:prstDash val="solid"/>
+                    </a:lnR>
+                    <a:lnT w="9525" cap="flat" cmpd="sng" algn="ctr">
+                      <a:solidFill>
+                        <a:srgbClr val="C9D3DD"/>
+                      </a:solidFill>
+                      <a:prstDash val="solid"/>
+                    </a:lnT>
+                    <a:lnB w="9525" cap="flat" cmpd="sng" algn="ctr">
+                      <a:solidFill>
+                        <a:srgbClr val="C9D3DD"/>
+                      </a:solidFill>
+                      <a:prstDash val="solid"/>
+                    </a:lnB>
+                    <a:solidFill>
+                      <a:srgbClr val="FFFFFF"/>
+                    </a:solidFill>
+                  </a:tcPr>
+                </a:tc>
+              </a:tr>
+            </a:tbl>
+          </a:graphicData>
+        </a:graphic>
+      </p:graphicFrame>
+    </p:spTree>
+  </p:cSld>
+  <p:clrMapOvr>
+    <a:masterClrMapping/>
+  </p:clrMapOvr>
+</p:sld>
+</file>
+
+<file path=ppt/slides/slide4.xml><?xml version="1.0" encoding="utf-8"?>
+<p:sld xmlns:a="http://schemas.openxmlformats.org/drawingml/2006/main" xmlns:p="http://schemas.openxmlformats.org/presentationml/2006/main" xmlns:r="http://schemas.openxmlformats.org/officeDocument/2006/relationships">
+  <p:cSld>
+    <p:spTree>
+      <p:nvGrpSpPr>
+        <p:cNvPr id="1" name=""/>
+        <p:cNvGrpSpPr/>
+        <p:nvPr/>
+      </p:nvGrpSpPr>
+      <p:grpSpPr/>
+      <p:sp>
+        <p:nvSpPr>
+          <p:cNvPr id="2" name="Mapa Silver - texto"/>
+          <p:cNvSpPr txBox="1"/>
+          <p:nvPr/>
+        </p:nvSpPr>
+        <p:spPr>
+          <a:xfrm>
+            <a:off x="320040" y="164592"/>
+            <a:ext cx="11548872" cy="201168"/>
+          </a:xfrm>
+          <a:prstGeom prst="rect">
+            <a:avLst/>
+          </a:prstGeom>
+          <a:noFill/>
+        </p:spPr>
+        <p:txBody>
+          <a:bodyPr wrap="square" lIns="0" rIns="0" tIns="0" bIns="0">
+            <a:spAutoFit/>
+          </a:bodyPr>
+          <a:lstStyle/>
+          <a:p>
+            <a:pPr algn="l">
+              <a:spcBef>
+                <a:spcPts val="0"/>
+              </a:spcBef>
+              <a:spcAft>
+                <a:spcPts val="0"/>
+              </a:spcAft>
+            </a:pPr>
+            <a:r>
+              <a:rPr sz="950" b="1">
+                <a:solidFill>
+                  <a:srgbClr val="E87722"/>
+                </a:solidFill>
+                <a:latin typeface="Calibri"/>
+              </a:rPr>
+              <a:t>PROYECTO INTEGRADOR · HITO S02 · EQUIPO 06</a:t>
+            </a:r>
+          </a:p>
+        </p:txBody>
+      </p:sp>
+      <p:sp>
+        <p:nvSpPr>
+          <p:cNvPr id="3" name="Mapa Silver - texto"/>
+          <p:cNvSpPr txBox="1"/>
+          <p:nvPr/>
+        </p:nvSpPr>
+        <p:spPr>
+          <a:xfrm>
+            <a:off x="320040" y="384048"/>
+            <a:ext cx="10607040" cy="420624"/>
+          </a:xfrm>
+          <a:prstGeom prst="rect">
+            <a:avLst/>
+          </a:prstGeom>
+          <a:noFill/>
+        </p:spPr>
+        <p:txBody>
+          <a:bodyPr wrap="square" lIns="0" rIns="0" tIns="0" bIns="0">
+            <a:spAutoFit/>
+          </a:bodyPr>
+          <a:lstStyle/>
+          <a:p>
+            <a:pPr algn="l">
+              <a:spcBef>
+                <a:spcPts val="0"/>
+              </a:spcBef>
+              <a:spcAft>
+                <a:spcPts val="0"/>
+              </a:spcAft>
+            </a:pPr>
+            <a:r>
+              <a:rPr sz="2400" b="1">
+                <a:solidFill>
+                  <a:srgbClr val="1F3A4D"/>
+                </a:solidFill>
+                <a:latin typeface="Calibri"/>
+              </a:rPr>
+              <a:t>Mapa Silver — 2/2</a:t>
+            </a:r>
+          </a:p>
+        </p:txBody>
+      </p:sp>
+      <p:sp>
+        <p:nvSpPr>
+          <p:cNvPr id="4" name="Mapa Silver - línea de acento"/>
+          <p:cNvSpPr/>
+          <p:nvPr/>
+        </p:nvSpPr>
+        <p:spPr>
+          <a:xfrm>
+            <a:off x="320040" y="841248"/>
+            <a:ext cx="11548872" cy="32004"/>
+          </a:xfrm>
+          <a:prstGeom prst="rect">
+            <a:avLst/>
+          </a:prstGeom>
+          <a:solidFill>
+            <a:srgbClr val="E87722"/>
+          </a:solidFill>
+          <a:ln>
+            <a:noFill/>
+          </a:ln>
+        </p:spPr>
+        <p:style>
+          <a:lnRef idx="1">
+            <a:schemeClr val="accent1"/>
+          </a:lnRef>
+          <a:fillRef idx="3">
+            <a:schemeClr val="accent1"/>
+          </a:fillRef>
+          <a:effectRef idx="2">
+            <a:schemeClr val="accent1"/>
+          </a:effectRef>
+          <a:fontRef idx="minor">
+            <a:schemeClr val="lt1"/>
+          </a:fontRef>
+        </p:style>
+        <p:txBody>
+          <a:bodyPr rtlCol="0" anchor="ctr"/>
+          <a:lstStyle/>
+          <a:p>
+            <a:pPr algn="ctr"/>
+          </a:p>
+        </p:txBody>
+      </p:sp>
+      <p:graphicFrame>
+        <p:nvGraphicFramePr>
+          <p:cNvPr id="5" name="Tabla Mapa Silver 2/2"/>
+          <p:cNvGraphicFramePr>
+            <a:graphicFrameLocks noGrp="1"/>
+          </p:cNvGraphicFramePr>
+          <p:nvPr/>
+        </p:nvGraphicFramePr>
+        <p:xfrm>
+          <a:off x="320040" y="932688"/>
+          <a:ext cx="11548872" cy="5029200"/>
+        </p:xfrm>
+        <a:graphic>
+          <a:graphicData uri="http://schemas.openxmlformats.org/drawingml/2006/table">
+            <a:tbl>
+              <a:tblPr firstRow="1"/>
+              <a:tblGrid>
+                <a:gridCol w="2331720"/>
+                <a:gridCol w="1152144"/>
+                <a:gridCol w="1554480"/>
+                <a:gridCol w="1883664"/>
+                <a:gridCol w="1097280"/>
+                <a:gridCol w="1645920"/>
+                <a:gridCol w="1883664"/>
+              </a:tblGrid>
+              <a:tr h="502920">
+                <a:tc>
+                  <a:txBody>
+                    <a:bodyPr wrap="square"/>
+                    <a:lstStyle/>
+                    <a:p>
+                      <a:pPr algn="ctr">
+                        <a:lnSpc>
+                          <a:spcPct val="100000"/>
+                        </a:lnSpc>
+                        <a:spcBef>
+                          <a:spcPts val="0"/>
+                        </a:spcBef>
+                        <a:spcAft>
+                          <a:spcPts val="0"/>
+                        </a:spcAft>
+                      </a:pPr>
+                      <a:r>
+                        <a:rPr sz="1050" b="1">
+                          <a:solidFill>
+                            <a:srgbClr val="FFFFFF"/>
+                          </a:solidFill>
+                          <a:latin typeface="Calibri"/>
+                        </a:rPr>
+                        <a:t>Archivo / tabla</a:t>
+                      </a:r>
+                    </a:p>
+                  </a:txBody>
+                  <a:tcPr anchor="ctr" marL="54864" marR="54864" marT="32004" marB="32004">
+                    <a:lnL w="9525" cap="flat" cmpd="sng" algn="ctr">
+                      <a:solidFill>
+                        <a:srgbClr val="FFFFFF"/>
+                      </a:solidFill>
+                      <a:prstDash val="solid"/>
+                    </a:lnL>
+                    <a:lnR w="9525" cap="flat" cmpd="sng" algn="ctr">
+                      <a:solidFill>
+                        <a:srgbClr val="FFFFFF"/>
+                      </a:solidFill>
+                      <a:prstDash val="solid"/>
+                    </a:lnR>
+                    <a:lnT w="9525" cap="flat" cmpd="sng" algn="ctr">
+                      <a:solidFill>
+                        <a:srgbClr val="FFFFFF"/>
+                      </a:solidFill>
+                      <a:prstDash val="solid"/>
+                    </a:lnT>
+                    <a:lnB w="9525" cap="flat" cmpd="sng" algn="ctr">
+                      <a:solidFill>
+                        <a:srgbClr val="FFFFFF"/>
+                      </a:solidFill>
+                      <a:prstDash val="solid"/>
+                    </a:lnB>
+                    <a:solidFill>
+                      <a:srgbClr val="243746"/>
+                    </a:solidFill>
+                  </a:tcPr>
+                </a:tc>
+                <a:tc>
+                  <a:txBody>
+                    <a:bodyPr wrap="square"/>
+                    <a:lstStyle/>
+                    <a:p>
+                      <a:pPr algn="ctr">
+                        <a:lnSpc>
+                          <a:spcPct val="100000"/>
+                        </a:lnSpc>
+                        <a:spcBef>
+                          <a:spcPts val="0"/>
+                        </a:spcBef>
+                        <a:spcAft>
+                          <a:spcPts val="0"/>
+                        </a:spcAft>
+                      </a:pPr>
+                      <a:r>
+                        <a:rPr sz="1050" b="1">
+                          <a:solidFill>
+                            <a:srgbClr val="FFFFFF"/>
+                          </a:solidFill>
+                          <a:latin typeface="Calibri"/>
+                        </a:rPr>
+                        <a:t>Granularidad</a:t>
+                      </a:r>
+                    </a:p>
+                  </a:txBody>
+                  <a:tcPr anchor="ctr" marL="54864" marR="54864" marT="32004" marB="32004">
+                    <a:lnL w="9525" cap="flat" cmpd="sng" algn="ctr">
+                      <a:solidFill>
+                        <a:srgbClr val="FFFFFF"/>
+                      </a:solidFill>
+                      <a:prstDash val="solid"/>
+                    </a:lnL>
+                    <a:lnR w="9525" cap="flat" cmpd="sng" algn="ctr">
+                      <a:solidFill>
+                        <a:srgbClr val="FFFFFF"/>
+                      </a:solidFill>
+                      <a:prstDash val="solid"/>
+                    </a:lnR>
+                    <a:lnT w="9525" cap="flat" cmpd="sng" algn="ctr">
+                      <a:solidFill>
+                        <a:srgbClr val="FFFFFF"/>
+                      </a:solidFill>
+                      <a:prstDash val="solid"/>
+                    </a:lnT>
+                    <a:lnB w="9525" cap="flat" cmpd="sng" algn="ctr">
+                      <a:solidFill>
+                        <a:srgbClr val="FFFFFF"/>
+                      </a:solidFill>
+                      <a:prstDash val="solid"/>
+                    </a:lnB>
+                    <a:solidFill>
+                      <a:srgbClr val="243746"/>
+                    </a:solidFill>
+                  </a:tcPr>
+                </a:tc>
+                <a:tc>
+                  <a:txBody>
+                    <a:bodyPr wrap="square"/>
+                    <a:lstStyle/>
+                    <a:p>
+                      <a:pPr algn="ctr">
+                        <a:lnSpc>
+                          <a:spcPct val="100000"/>
+                        </a:lnSpc>
+                        <a:spcBef>
+                          <a:spcPts val="0"/>
+                        </a:spcBef>
+                        <a:spcAft>
+                          <a:spcPts val="0"/>
+                        </a:spcAft>
+                      </a:pPr>
+                      <a:r>
+                        <a:rPr sz="1050" b="1">
+                          <a:solidFill>
+                            <a:srgbClr val="FFFFFF"/>
+                          </a:solidFill>
+                          <a:latin typeface="Calibri"/>
+                        </a:rPr>
+                        <a:t>Identificador único</a:t>
+                      </a:r>
+                    </a:p>
+                  </a:txBody>
+                  <a:tcPr anchor="ctr" marL="54864" marR="54864" marT="32004" marB="32004">
+                    <a:lnL w="9525" cap="flat" cmpd="sng" algn="ctr">
+                      <a:solidFill>
+                        <a:srgbClr val="FFFFFF"/>
+                      </a:solidFill>
+                      <a:prstDash val="solid"/>
+                    </a:lnL>
+                    <a:lnR w="9525" cap="flat" cmpd="sng" algn="ctr">
+                      <a:solidFill>
+                        <a:srgbClr val="FFFFFF"/>
+                      </a:solidFill>
+                      <a:prstDash val="solid"/>
+                    </a:lnR>
+                    <a:lnT w="9525" cap="flat" cmpd="sng" algn="ctr">
+                      <a:solidFill>
+                        <a:srgbClr val="FFFFFF"/>
+                      </a:solidFill>
+                      <a:prstDash val="solid"/>
+                    </a:lnT>
+                    <a:lnB w="9525" cap="flat" cmpd="sng" algn="ctr">
+                      <a:solidFill>
+                        <a:srgbClr val="FFFFFF"/>
+                      </a:solidFill>
+                      <a:prstDash val="solid"/>
+                    </a:lnB>
+                    <a:solidFill>
+                      <a:srgbClr val="243746"/>
+                    </a:solidFill>
+                  </a:tcPr>
+                </a:tc>
+                <a:tc>
+                  <a:txBody>
+                    <a:bodyPr wrap="square"/>
+                    <a:lstStyle/>
+                    <a:p>
+                      <a:pPr algn="ctr">
+                        <a:lnSpc>
+                          <a:spcPct val="100000"/>
+                        </a:lnSpc>
+                        <a:spcBef>
+                          <a:spcPts val="0"/>
+                        </a:spcBef>
+                        <a:spcAft>
+                          <a:spcPts val="0"/>
+                        </a:spcAft>
+                      </a:pPr>
+                      <a:r>
+                        <a:rPr sz="1050" b="1">
+                          <a:solidFill>
+                            <a:srgbClr val="FFFFFF"/>
+                          </a:solidFill>
+                          <a:latin typeface="Calibri"/>
+                        </a:rPr>
+                        <a:t>Frecuencia</a:t>
+                      </a:r>
+                    </a:p>
+                  </a:txBody>
+                  <a:tcPr anchor="ctr" marL="54864" marR="54864" marT="32004" marB="32004">
+                    <a:lnL w="9525" cap="flat" cmpd="sng" algn="ctr">
+                      <a:solidFill>
+                        <a:srgbClr val="FFFFFF"/>
+                      </a:solidFill>
+                      <a:prstDash val="solid"/>
+                    </a:lnL>
+                    <a:lnR w="9525" cap="flat" cmpd="sng" algn="ctr">
+                      <a:solidFill>
+                        <a:srgbClr val="FFFFFF"/>
+                      </a:solidFill>
+                      <a:prstDash val="solid"/>
+                    </a:lnR>
+                    <a:lnT w="9525" cap="flat" cmpd="sng" algn="ctr">
+                      <a:solidFill>
+                        <a:srgbClr val="FFFFFF"/>
+                      </a:solidFill>
+                      <a:prstDash val="solid"/>
+                    </a:lnT>
+                    <a:lnB w="9525" cap="flat" cmpd="sng" algn="ctr">
+                      <a:solidFill>
+                        <a:srgbClr val="FFFFFF"/>
+                      </a:solidFill>
+                      <a:prstDash val="solid"/>
+                    </a:lnB>
+                    <a:solidFill>
+                      <a:srgbClr val="243746"/>
+                    </a:solidFill>
+                  </a:tcPr>
+                </a:tc>
+                <a:tc>
+                  <a:txBody>
+                    <a:bodyPr wrap="square"/>
+                    <a:lstStyle/>
+                    <a:p>
+                      <a:pPr algn="ctr">
+                        <a:lnSpc>
+                          <a:spcPct val="100000"/>
+                        </a:lnSpc>
+                        <a:spcBef>
+                          <a:spcPts val="0"/>
+                        </a:spcBef>
+                        <a:spcAft>
+                          <a:spcPts val="0"/>
+                        </a:spcAft>
+                      </a:pPr>
+                      <a:r>
+                        <a:rPr sz="1050" b="1">
+                          <a:solidFill>
+                            <a:srgbClr val="FFFFFF"/>
+                          </a:solidFill>
+                          <a:latin typeface="Calibri"/>
+                        </a:rPr>
+                        <a:t>Propietario</a:t>
+                      </a:r>
+                    </a:p>
+                  </a:txBody>
+                  <a:tcPr anchor="ctr" marL="54864" marR="54864" marT="32004" marB="32004">
+                    <a:lnL w="9525" cap="flat" cmpd="sng" algn="ctr">
+                      <a:solidFill>
+                        <a:srgbClr val="FFFFFF"/>
+                      </a:solidFill>
+                      <a:prstDash val="solid"/>
+                    </a:lnL>
+                    <a:lnR w="9525" cap="flat" cmpd="sng" algn="ctr">
+                      <a:solidFill>
+                        <a:srgbClr val="FFFFFF"/>
+                      </a:solidFill>
+                      <a:prstDash val="solid"/>
+                    </a:lnR>
+                    <a:lnT w="9525" cap="flat" cmpd="sng" algn="ctr">
+                      <a:solidFill>
+                        <a:srgbClr val="FFFFFF"/>
+                      </a:solidFill>
+                      <a:prstDash val="solid"/>
+                    </a:lnT>
+                    <a:lnB w="9525" cap="flat" cmpd="sng" algn="ctr">
+                      <a:solidFill>
+                        <a:srgbClr val="FFFFFF"/>
+                      </a:solidFill>
+                      <a:prstDash val="solid"/>
+                    </a:lnB>
+                    <a:solidFill>
+                      <a:srgbClr val="243746"/>
+                    </a:solidFill>
+                  </a:tcPr>
+                </a:tc>
+                <a:tc>
+                  <a:txBody>
+                    <a:bodyPr wrap="square"/>
+                    <a:lstStyle/>
+                    <a:p>
+                      <a:pPr algn="ctr">
+                        <a:lnSpc>
+                          <a:spcPct val="100000"/>
+                        </a:lnSpc>
+                        <a:spcBef>
+                          <a:spcPts val="0"/>
+                        </a:spcBef>
+                        <a:spcAft>
+                          <a:spcPts val="0"/>
+                        </a:spcAft>
+                      </a:pPr>
+                      <a:r>
+                        <a:rPr sz="1050" b="1">
+                          <a:solidFill>
+                            <a:srgbClr val="FFFFFF"/>
+                          </a:solidFill>
+                          <a:latin typeface="Calibri"/>
+                        </a:rPr>
+                        <a:t>Riesgo</a:t>
+                      </a:r>
+                    </a:p>
+                  </a:txBody>
+                  <a:tcPr anchor="ctr" marL="54864" marR="54864" marT="32004" marB="32004">
+                    <a:lnL w="9525" cap="flat" cmpd="sng" algn="ctr">
+                      <a:solidFill>
+                        <a:srgbClr val="FFFFFF"/>
+                      </a:solidFill>
+                      <a:prstDash val="solid"/>
+                    </a:lnL>
+                    <a:lnR w="9525" cap="flat" cmpd="sng" algn="ctr">
+                      <a:solidFill>
+                        <a:srgbClr val="FFFFFF"/>
+                      </a:solidFill>
+                      <a:prstDash val="solid"/>
+                    </a:lnR>
+                    <a:lnT w="9525" cap="flat" cmpd="sng" algn="ctr">
+                      <a:solidFill>
+                        <a:srgbClr val="FFFFFF"/>
+                      </a:solidFill>
+                      <a:prstDash val="solid"/>
+                    </a:lnT>
+                    <a:lnB w="9525" cap="flat" cmpd="sng" algn="ctr">
+                      <a:solidFill>
+                        <a:srgbClr val="FFFFFF"/>
+                      </a:solidFill>
+                      <a:prstDash val="solid"/>
+                    </a:lnB>
+                    <a:solidFill>
+                      <a:srgbClr val="243746"/>
+                    </a:solidFill>
+                  </a:tcPr>
+                </a:tc>
+                <a:tc>
+                  <a:txBody>
+                    <a:bodyPr wrap="square"/>
+                    <a:lstStyle/>
+                    <a:p>
+                      <a:pPr algn="ctr">
+                        <a:lnSpc>
+                          <a:spcPct val="100000"/>
+                        </a:lnSpc>
+                        <a:spcBef>
+                          <a:spcPts val="0"/>
+                        </a:spcBef>
+                        <a:spcAft>
+                          <a:spcPts val="0"/>
+                        </a:spcAft>
+                      </a:pPr>
+                      <a:r>
+                        <a:rPr sz="1050" b="1">
+                          <a:solidFill>
+                            <a:srgbClr val="FFFFFF"/>
+                          </a:solidFill>
+                          <a:latin typeface="Calibri"/>
+                        </a:rPr>
+                        <a:t>Control propuesto</a:t>
+                      </a:r>
+                    </a:p>
+                  </a:txBody>
+                  <a:tcPr anchor="ctr" marL="54864" marR="54864" marT="32004" marB="32004">
+                    <a:lnL w="9525" cap="flat" cmpd="sng" algn="ctr">
+                      <a:solidFill>
+                        <a:srgbClr val="FFFFFF"/>
+                      </a:solidFill>
+                      <a:prstDash val="solid"/>
+                    </a:lnL>
+                    <a:lnR w="9525" cap="flat" cmpd="sng" algn="ctr">
+                      <a:solidFill>
+                        <a:srgbClr val="FFFFFF"/>
+                      </a:solidFill>
+                      <a:prstDash val="solid"/>
+                    </a:lnR>
+                    <a:lnT w="9525" cap="flat" cmpd="sng" algn="ctr">
+                      <a:solidFill>
+                        <a:srgbClr val="FFFFFF"/>
+                      </a:solidFill>
+                      <a:prstDash val="solid"/>
+                    </a:lnT>
+                    <a:lnB w="9525" cap="flat" cmpd="sng" algn="ctr">
+                      <a:solidFill>
+                        <a:srgbClr val="FFFFFF"/>
+                      </a:solidFill>
+                      <a:prstDash val="solid"/>
+                    </a:lnB>
+                    <a:solidFill>
+                      <a:srgbClr val="243746"/>
+                    </a:solidFill>
+                  </a:tcPr>
+                </a:tc>
+              </a:tr>
+              <a:tr h="2263140">
+                <a:tc>
+                  <a:txBody>
+                    <a:bodyPr wrap="square"/>
+                    <a:lstStyle/>
+                    <a:p>
+                      <a:pPr algn="l">
+                        <a:lnSpc>
+                          <a:spcPct val="100000"/>
+                        </a:lnSpc>
+                        <a:spcBef>
+                          <a:spcPts val="0"/>
+                        </a:spcBef>
+                        <a:spcAft>
+                          <a:spcPts val="0"/>
+                        </a:spcAft>
+                      </a:pPr>
+                      <a:r>
+                        <a:rPr sz="1050" b="0">
+                          <a:solidFill>
+                            <a:srgbClr val="263442"/>
+                          </a:solidFill>
+                          <a:latin typeface="Calibri"/>
+                        </a:rPr>
+                        <a:t>andinalog_inventory_tracking_silver.csv</a:t>
+                      </a:r>
+                    </a:p>
+                  </a:txBody>
+                  <a:tcPr anchor="ctr" marL="54864" marR="54864" marT="32004" marB="32004">
+                    <a:lnL w="9525" cap="flat" cmpd="sng" algn="ctr">
+                      <a:solidFill>
+                        <a:srgbClr val="C9D3DD"/>
+                      </a:solidFill>
+                      <a:prstDash val="solid"/>
+                    </a:lnL>
+                    <a:lnR w="9525" cap="flat" cmpd="sng" algn="ctr">
+                      <a:solidFill>
+                        <a:srgbClr val="C9D3DD"/>
+                      </a:solidFill>
+                      <a:prstDash val="solid"/>
+                    </a:lnR>
+                    <a:lnT w="9525" cap="flat" cmpd="sng" algn="ctr">
+                      <a:solidFill>
+                        <a:srgbClr val="C9D3DD"/>
+                      </a:solidFill>
+                      <a:prstDash val="solid"/>
+                    </a:lnT>
+                    <a:lnB w="9525" cap="flat" cmpd="sng" algn="ctr">
+                      <a:solidFill>
+                        <a:srgbClr val="C9D3DD"/>
+                      </a:solidFill>
+                      <a:prstDash val="solid"/>
+                    </a:lnB>
+                    <a:solidFill>
+                      <a:srgbClr val="FFFFFF"/>
+                    </a:solidFill>
+                  </a:tcPr>
+                </a:tc>
+                <a:tc>
+                  <a:txBody>
+                    <a:bodyPr wrap="square"/>
+                    <a:lstStyle/>
+                    <a:p>
+                      <a:pPr algn="l">
+                        <a:lnSpc>
+                          <a:spcPct val="100000"/>
+                        </a:lnSpc>
+                        <a:spcBef>
+                          <a:spcPts val="0"/>
+                        </a:spcBef>
+                        <a:spcAft>
+                          <a:spcPts val="0"/>
+                        </a:spcAft>
+                      </a:pPr>
+                      <a:r>
+                        <a:rPr sz="1050" b="0">
+                          <a:solidFill>
+                            <a:srgbClr val="263442"/>
+                          </a:solidFill>
+                          <a:latin typeface="Calibri"/>
+                        </a:rPr>
+                        <a:t>Un lote con ingreso, salida y merma en esta entrega</a:t>
+                      </a:r>
+                    </a:p>
+                  </a:txBody>
+                  <a:tcPr anchor="ctr" marL="54864" marR="54864" marT="32004" marB="32004">
+                    <a:lnL w="9525" cap="flat" cmpd="sng" algn="ctr">
+                      <a:solidFill>
+                        <a:srgbClr val="C9D3DD"/>
+                      </a:solidFill>
+                      <a:prstDash val="solid"/>
+                    </a:lnL>
+                    <a:lnR w="9525" cap="flat" cmpd="sng" algn="ctr">
+                      <a:solidFill>
+                        <a:srgbClr val="C9D3DD"/>
+                      </a:solidFill>
+                      <a:prstDash val="solid"/>
+                    </a:lnR>
+                    <a:lnT w="9525" cap="flat" cmpd="sng" algn="ctr">
+                      <a:solidFill>
+                        <a:srgbClr val="C9D3DD"/>
+                      </a:solidFill>
+                      <a:prstDash val="solid"/>
+                    </a:lnT>
+                    <a:lnB w="9525" cap="flat" cmpd="sng" algn="ctr">
+                      <a:solidFill>
+                        <a:srgbClr val="C9D3DD"/>
+                      </a:solidFill>
+                      <a:prstDash val="solid"/>
+                    </a:lnB>
+                    <a:solidFill>
+                      <a:srgbClr val="FFFFFF"/>
+                    </a:solidFill>
+                  </a:tcPr>
+                </a:tc>
+                <a:tc>
+                  <a:txBody>
+                    <a:bodyPr wrap="square"/>
+                    <a:lstStyle/>
+                    <a:p>
+                      <a:pPr algn="l">
+                        <a:lnSpc>
+                          <a:spcPct val="100000"/>
+                        </a:lnSpc>
+                        <a:spcBef>
+                          <a:spcPts val="0"/>
+                        </a:spcBef>
+                        <a:spcAft>
+                          <a:spcPts val="0"/>
+                        </a:spcAft>
+                      </a:pPr>
+                      <a:r>
+                        <a:rPr sz="1050" b="0">
+                          <a:solidFill>
+                            <a:srgbClr val="263442"/>
+                          </a:solidFill>
+                          <a:latin typeface="Calibri"/>
+                        </a:rPr>
+                        <a:t>lote_id; movimiento_id único en esta entrega</a:t>
+                      </a:r>
+                    </a:p>
+                  </a:txBody>
+                  <a:tcPr anchor="ctr" marL="54864" marR="54864" marT="32004" marB="32004">
+                    <a:lnL w="9525" cap="flat" cmpd="sng" algn="ctr">
+                      <a:solidFill>
+                        <a:srgbClr val="C9D3DD"/>
+                      </a:solidFill>
+                      <a:prstDash val="solid"/>
+                    </a:lnL>
+                    <a:lnR w="9525" cap="flat" cmpd="sng" algn="ctr">
+                      <a:solidFill>
+                        <a:srgbClr val="C9D3DD"/>
+                      </a:solidFill>
+                      <a:prstDash val="solid"/>
+                    </a:lnR>
+                    <a:lnT w="9525" cap="flat" cmpd="sng" algn="ctr">
+                      <a:solidFill>
+                        <a:srgbClr val="C9D3DD"/>
+                      </a:solidFill>
+                      <a:prstDash val="solid"/>
+                    </a:lnT>
+                    <a:lnB w="9525" cap="flat" cmpd="sng" algn="ctr">
+                      <a:solidFill>
+                        <a:srgbClr val="C9D3DD"/>
+                      </a:solidFill>
+                      <a:prstDash val="solid"/>
+                    </a:lnB>
+                    <a:solidFill>
+                      <a:srgbClr val="FFFFFF"/>
+                    </a:solidFill>
+                  </a:tcPr>
+                </a:tc>
+                <a:tc>
+                  <a:txBody>
+                    <a:bodyPr wrap="square"/>
+                    <a:lstStyle/>
+                    <a:p>
+                      <a:pPr algn="l">
+                        <a:lnSpc>
+                          <a:spcPct val="100000"/>
+                        </a:lnSpc>
+                        <a:spcBef>
+                          <a:spcPts val="0"/>
+                        </a:spcBef>
+                        <a:spcAft>
+                          <a:spcPts val="0"/>
+                        </a:spcAft>
+                      </a:pPr>
+                      <a:r>
+                        <a:rPr sz="1050" b="0">
+                          <a:solidFill>
+                            <a:srgbClr val="263442"/>
+                          </a:solidFill>
+                          <a:latin typeface="Calibri"/>
+                        </a:rPr>
+                        <a:t>Sin periodicidad fija: una fila por lote contiene las fechas de ingreso y salida; actualización por acordar</a:t>
+                      </a:r>
+                    </a:p>
+                  </a:txBody>
+                  <a:tcPr anchor="ctr" marL="54864" marR="54864" marT="32004" marB="32004">
+                    <a:lnL w="9525" cap="flat" cmpd="sng" algn="ctr">
+                      <a:solidFill>
+                        <a:srgbClr val="C9D3DD"/>
+                      </a:solidFill>
+                      <a:prstDash val="solid"/>
+                    </a:lnL>
+                    <a:lnR w="9525" cap="flat" cmpd="sng" algn="ctr">
+                      <a:solidFill>
+                        <a:srgbClr val="C9D3DD"/>
+                      </a:solidFill>
+                      <a:prstDash val="solid"/>
+                    </a:lnR>
+                    <a:lnT w="9525" cap="flat" cmpd="sng" algn="ctr">
+                      <a:solidFill>
+                        <a:srgbClr val="C9D3DD"/>
+                      </a:solidFill>
+                      <a:prstDash val="solid"/>
+                    </a:lnT>
+                    <a:lnB w="9525" cap="flat" cmpd="sng" algn="ctr">
+                      <a:solidFill>
+                        <a:srgbClr val="C9D3DD"/>
+                      </a:solidFill>
+                      <a:prstDash val="solid"/>
+                    </a:lnB>
+                    <a:solidFill>
+                      <a:srgbClr val="FFFFFF"/>
+                    </a:solidFill>
+                  </a:tcPr>
+                </a:tc>
+                <a:tc>
+                  <a:txBody>
+                    <a:bodyPr wrap="square"/>
+                    <a:lstStyle/>
+                    <a:p>
+                      <a:pPr algn="l">
+                        <a:lnSpc>
+                          <a:spcPct val="100000"/>
+                        </a:lnSpc>
+                        <a:spcBef>
+                          <a:spcPts val="0"/>
+                        </a:spcBef>
+                        <a:spcAft>
+                          <a:spcPts val="0"/>
+                        </a:spcAft>
+                      </a:pPr>
+                      <a:r>
+                        <a:rPr sz="1050" b="0">
+                          <a:solidFill>
+                            <a:srgbClr val="263442"/>
+                          </a:solidFill>
+                          <a:latin typeface="Calibri"/>
+                        </a:rPr>
+                        <a:t>Por acordar; revisión Grupo 06</a:t>
+                      </a:r>
+                    </a:p>
+                  </a:txBody>
+                  <a:tcPr anchor="ctr" marL="54864" marR="54864" marT="32004" marB="32004">
+                    <a:lnL w="9525" cap="flat" cmpd="sng" algn="ctr">
+                      <a:solidFill>
+                        <a:srgbClr val="C9D3DD"/>
+                      </a:solidFill>
+                      <a:prstDash val="solid"/>
+                    </a:lnL>
+                    <a:lnR w="9525" cap="flat" cmpd="sng" algn="ctr">
+                      <a:solidFill>
+                        <a:srgbClr val="C9D3DD"/>
+                      </a:solidFill>
+                      <a:prstDash val="solid"/>
+                    </a:lnR>
+                    <a:lnT w="9525" cap="flat" cmpd="sng" algn="ctr">
+                      <a:solidFill>
+                        <a:srgbClr val="C9D3DD"/>
+                      </a:solidFill>
+                      <a:prstDash val="solid"/>
+                    </a:lnT>
+                    <a:lnB w="9525" cap="flat" cmpd="sng" algn="ctr">
+                      <a:solidFill>
+                        <a:srgbClr val="C9D3DD"/>
+                      </a:solidFill>
+                      <a:prstDash val="solid"/>
+                    </a:lnB>
+                    <a:solidFill>
+                      <a:srgbClr val="FFFFFF"/>
+                    </a:solidFill>
+                  </a:tcPr>
+                </a:tc>
+                <a:tc>
+                  <a:txBody>
+                    <a:bodyPr wrap="square"/>
+                    <a:lstStyle/>
+                    <a:p>
+                      <a:pPr algn="l">
+                        <a:lnSpc>
+                          <a:spcPct val="100000"/>
+                        </a:lnSpc>
+                        <a:spcBef>
+                          <a:spcPts val="0"/>
+                        </a:spcBef>
+                        <a:spcAft>
+                          <a:spcPts val="0"/>
+                        </a:spcAft>
+                      </a:pPr>
+                      <a:r>
+                        <a:rPr sz="1050" b="0">
+                          <a:solidFill>
+                            <a:srgbClr val="263442"/>
+                          </a:solidFill>
+                          <a:latin typeface="Calibri"/>
+                        </a:rPr>
+                        <a:t>Leer vencimiento como stock vigente</a:t>
+                      </a:r>
+                    </a:p>
+                  </a:txBody>
+                  <a:tcPr anchor="ctr" marL="54864" marR="54864" marT="32004" marB="32004">
+                    <a:lnL w="9525" cap="flat" cmpd="sng" algn="ctr">
+                      <a:solidFill>
+                        <a:srgbClr val="C9D3DD"/>
+                      </a:solidFill>
+                      <a:prstDash val="solid"/>
+                    </a:lnL>
+                    <a:lnR w="9525" cap="flat" cmpd="sng" algn="ctr">
+                      <a:solidFill>
+                        <a:srgbClr val="C9D3DD"/>
+                      </a:solidFill>
+                      <a:prstDash val="solid"/>
+                    </a:lnR>
+                    <a:lnT w="9525" cap="flat" cmpd="sng" algn="ctr">
+                      <a:solidFill>
+                        <a:srgbClr val="C9D3DD"/>
+                      </a:solidFill>
+                      <a:prstDash val="solid"/>
+                    </a:lnT>
+                    <a:lnB w="9525" cap="flat" cmpd="sng" algn="ctr">
+                      <a:solidFill>
+                        <a:srgbClr val="C9D3DD"/>
+                      </a:solidFill>
+                      <a:prstDash val="solid"/>
+                    </a:lnB>
+                    <a:solidFill>
+                      <a:srgbClr val="FFFFFF"/>
+                    </a:solidFill>
+                  </a:tcPr>
+                </a:tc>
+                <a:tc>
+                  <a:txBody>
+                    <a:bodyPr wrap="square"/>
+                    <a:lstStyle/>
+                    <a:p>
+                      <a:pPr algn="l">
+                        <a:lnSpc>
+                          <a:spcPct val="100000"/>
+                        </a:lnSpc>
+                        <a:spcBef>
+                          <a:spcPts val="0"/>
+                        </a:spcBef>
+                        <a:spcAft>
+                          <a:spcPts val="0"/>
+                        </a:spcAft>
+                      </a:pPr>
+                      <a:r>
+                        <a:rPr sz="1050" b="0">
+                          <a:solidFill>
+                            <a:srgbClr val="263442"/>
+                          </a:solidFill>
+                          <a:latin typeface="Calibri"/>
+                        </a:rPr>
+                        <a:t>Declarar que todos los lotes salieron; KPI históricos</a:t>
+                      </a:r>
+                    </a:p>
+                  </a:txBody>
+                  <a:tcPr anchor="ctr" marL="54864" marR="54864" marT="32004" marB="32004">
+                    <a:lnL w="9525" cap="flat" cmpd="sng" algn="ctr">
+                      <a:solidFill>
+                        <a:srgbClr val="C9D3DD"/>
+                      </a:solidFill>
+                      <a:prstDash val="solid"/>
+                    </a:lnL>
+                    <a:lnR w="9525" cap="flat" cmpd="sng" algn="ctr">
+                      <a:solidFill>
+                        <a:srgbClr val="C9D3DD"/>
+                      </a:solidFill>
+                      <a:prstDash val="solid"/>
+                    </a:lnR>
+                    <a:lnT w="9525" cap="flat" cmpd="sng" algn="ctr">
+                      <a:solidFill>
+                        <a:srgbClr val="C9D3DD"/>
+                      </a:solidFill>
+                      <a:prstDash val="solid"/>
+                    </a:lnT>
+                    <a:lnB w="9525" cap="flat" cmpd="sng" algn="ctr">
+                      <a:solidFill>
+                        <a:srgbClr val="C9D3DD"/>
+                      </a:solidFill>
+                      <a:prstDash val="solid"/>
+                    </a:lnB>
+                    <a:solidFill>
+                      <a:srgbClr val="FFFFFF"/>
+                    </a:solidFill>
+                  </a:tcPr>
+                </a:tc>
+              </a:tr>
+              <a:tr h="2263140">
+                <a:tc>
+                  <a:txBody>
+                    <a:bodyPr wrap="square"/>
+                    <a:lstStyle/>
+                    <a:p>
+                      <a:pPr algn="l">
+                        <a:lnSpc>
+                          <a:spcPct val="100000"/>
+                        </a:lnSpc>
+                        <a:spcBef>
+                          <a:spcPts val="0"/>
+                        </a:spcBef>
+                        <a:spcAft>
+                          <a:spcPts val="0"/>
+                        </a:spcAft>
+                      </a:pPr>
+                      <a:r>
+                        <a:rPr sz="1050" b="0">
+                          <a:solidFill>
+                            <a:srgbClr val="263442"/>
+                          </a:solidFill>
+                          <a:latin typeface="Calibri"/>
+                        </a:rPr>
+                        <a:t>andinalog_warehouse_costs_silver.csv</a:t>
+                      </a:r>
+                    </a:p>
+                  </a:txBody>
+                  <a:tcPr anchor="ctr" marL="54864" marR="54864" marT="32004" marB="32004">
+                    <a:lnL w="9525" cap="flat" cmpd="sng" algn="ctr">
+                      <a:solidFill>
+                        <a:srgbClr val="C9D3DD"/>
+                      </a:solidFill>
+                      <a:prstDash val="solid"/>
+                    </a:lnL>
+                    <a:lnR w="9525" cap="flat" cmpd="sng" algn="ctr">
+                      <a:solidFill>
+                        <a:srgbClr val="C9D3DD"/>
+                      </a:solidFill>
+                      <a:prstDash val="solid"/>
+                    </a:lnR>
+                    <a:lnT w="9525" cap="flat" cmpd="sng" algn="ctr">
+                      <a:solidFill>
+                        <a:srgbClr val="C9D3DD"/>
+                      </a:solidFill>
+                      <a:prstDash val="solid"/>
+                    </a:lnT>
+                    <a:lnB w="9525" cap="flat" cmpd="sng" algn="ctr">
+                      <a:solidFill>
+                        <a:srgbClr val="C9D3DD"/>
+                      </a:solidFill>
+                      <a:prstDash val="solid"/>
+                    </a:lnB>
+                    <a:solidFill>
+                      <a:srgbClr val="F2F6F9"/>
+                    </a:solidFill>
+                  </a:tcPr>
+                </a:tc>
+                <a:tc>
+                  <a:txBody>
+                    <a:bodyPr wrap="square"/>
+                    <a:lstStyle/>
+                    <a:p>
+                      <a:pPr algn="l">
+                        <a:lnSpc>
+                          <a:spcPct val="100000"/>
+                        </a:lnSpc>
+                        <a:spcBef>
+                          <a:spcPts val="0"/>
+                        </a:spcBef>
+                        <a:spcAft>
+                          <a:spcPts val="0"/>
+                        </a:spcAft>
+                      </a:pPr>
+                      <a:r>
+                        <a:rPr sz="1050" b="0">
+                          <a:solidFill>
+                            <a:srgbClr val="263442"/>
+                          </a:solidFill>
+                          <a:latin typeface="Calibri"/>
+                        </a:rPr>
+                        <a:t>Un centro en un mes</a:t>
+                      </a:r>
+                    </a:p>
+                  </a:txBody>
+                  <a:tcPr anchor="ctr" marL="54864" marR="54864" marT="32004" marB="32004">
+                    <a:lnL w="9525" cap="flat" cmpd="sng" algn="ctr">
+                      <a:solidFill>
+                        <a:srgbClr val="C9D3DD"/>
+                      </a:solidFill>
+                      <a:prstDash val="solid"/>
+                    </a:lnL>
+                    <a:lnR w="9525" cap="flat" cmpd="sng" algn="ctr">
+                      <a:solidFill>
+                        <a:srgbClr val="C9D3DD"/>
+                      </a:solidFill>
+                      <a:prstDash val="solid"/>
+                    </a:lnR>
+                    <a:lnT w="9525" cap="flat" cmpd="sng" algn="ctr">
+                      <a:solidFill>
+                        <a:srgbClr val="C9D3DD"/>
+                      </a:solidFill>
+                      <a:prstDash val="solid"/>
+                    </a:lnT>
+                    <a:lnB w="9525" cap="flat" cmpd="sng" algn="ctr">
+                      <a:solidFill>
+                        <a:srgbClr val="C9D3DD"/>
+                      </a:solidFill>
+                      <a:prstDash val="solid"/>
+                    </a:lnB>
+                    <a:solidFill>
+                      <a:srgbClr val="F2F6F9"/>
+                    </a:solidFill>
+                  </a:tcPr>
+                </a:tc>
+                <a:tc>
+                  <a:txBody>
+                    <a:bodyPr wrap="square"/>
+                    <a:lstStyle/>
+                    <a:p>
+                      <a:pPr algn="l">
+                        <a:lnSpc>
+                          <a:spcPct val="100000"/>
+                        </a:lnSpc>
+                        <a:spcBef>
+                          <a:spcPts val="0"/>
+                        </a:spcBef>
+                        <a:spcAft>
+                          <a:spcPts val="0"/>
+                        </a:spcAft>
+                      </a:pPr>
+                      <a:r>
+                        <a:rPr sz="1050" b="0">
+                          <a:solidFill>
+                            <a:srgbClr val="263442"/>
+                          </a:solidFill>
+                          <a:latin typeface="Calibri"/>
+                        </a:rPr>
+                        <a:t>centro_distribucion + periodo_mes</a:t>
+                      </a:r>
+                    </a:p>
+                  </a:txBody>
+                  <a:tcPr anchor="ctr" marL="54864" marR="54864" marT="32004" marB="32004">
+                    <a:lnL w="9525" cap="flat" cmpd="sng" algn="ctr">
+                      <a:solidFill>
+                        <a:srgbClr val="C9D3DD"/>
+                      </a:solidFill>
+                      <a:prstDash val="solid"/>
+                    </a:lnL>
+                    <a:lnR w="9525" cap="flat" cmpd="sng" algn="ctr">
+                      <a:solidFill>
+                        <a:srgbClr val="C9D3DD"/>
+                      </a:solidFill>
+                      <a:prstDash val="solid"/>
+                    </a:lnR>
+                    <a:lnT w="9525" cap="flat" cmpd="sng" algn="ctr">
+                      <a:solidFill>
+                        <a:srgbClr val="C9D3DD"/>
+                      </a:solidFill>
+                      <a:prstDash val="solid"/>
+                    </a:lnT>
+                    <a:lnB w="9525" cap="flat" cmpd="sng" algn="ctr">
+                      <a:solidFill>
+                        <a:srgbClr val="C9D3DD"/>
+                      </a:solidFill>
+                      <a:prstDash val="solid"/>
+                    </a:lnB>
+                    <a:solidFill>
+                      <a:srgbClr val="F2F6F9"/>
+                    </a:solidFill>
+                  </a:tcPr>
+                </a:tc>
+                <a:tc>
+                  <a:txBody>
+                    <a:bodyPr wrap="square"/>
+                    <a:lstStyle/>
+                    <a:p>
+                      <a:pPr algn="l">
+                        <a:lnSpc>
+                          <a:spcPct val="100000"/>
+                        </a:lnSpc>
+                        <a:spcBef>
+                          <a:spcPts val="0"/>
+                        </a:spcBef>
+                        <a:spcAft>
+                          <a:spcPts val="0"/>
+                        </a:spcAft>
+                      </a:pPr>
+                      <a:r>
+                        <a:rPr sz="1050" b="0">
+                          <a:solidFill>
+                            <a:srgbClr val="263442"/>
+                          </a:solidFill>
+                          <a:latin typeface="Calibri"/>
+                        </a:rPr>
+                        <a:t>Mensual; actualización por acordar</a:t>
+                      </a:r>
+                    </a:p>
+                  </a:txBody>
+                  <a:tcPr anchor="ctr" marL="54864" marR="54864" marT="32004" marB="32004">
+                    <a:lnL w="9525" cap="flat" cmpd="sng" algn="ctr">
+                      <a:solidFill>
+                        <a:srgbClr val="C9D3DD"/>
+                      </a:solidFill>
+                      <a:prstDash val="solid"/>
+                    </a:lnL>
+                    <a:lnR w="9525" cap="flat" cmpd="sng" algn="ctr">
+                      <a:solidFill>
+                        <a:srgbClr val="C9D3DD"/>
+                      </a:solidFill>
+                      <a:prstDash val="solid"/>
+                    </a:lnR>
+                    <a:lnT w="9525" cap="flat" cmpd="sng" algn="ctr">
+                      <a:solidFill>
+                        <a:srgbClr val="C9D3DD"/>
+                      </a:solidFill>
+                      <a:prstDash val="solid"/>
+                    </a:lnT>
+                    <a:lnB w="9525" cap="flat" cmpd="sng" algn="ctr">
+                      <a:solidFill>
+                        <a:srgbClr val="C9D3DD"/>
+                      </a:solidFill>
+                      <a:prstDash val="solid"/>
+                    </a:lnB>
+                    <a:solidFill>
+                      <a:srgbClr val="F2F6F9"/>
+                    </a:solidFill>
+                  </a:tcPr>
+                </a:tc>
+                <a:tc>
+                  <a:txBody>
+                    <a:bodyPr wrap="square"/>
+                    <a:lstStyle/>
+                    <a:p>
+                      <a:pPr algn="l">
+                        <a:lnSpc>
+                          <a:spcPct val="100000"/>
+                        </a:lnSpc>
+                        <a:spcBef>
+                          <a:spcPts val="0"/>
+                        </a:spcBef>
+                        <a:spcAft>
+                          <a:spcPts val="0"/>
+                        </a:spcAft>
+                      </a:pPr>
+                      <a:r>
+                        <a:rPr sz="1050" b="0">
+                          <a:solidFill>
+                            <a:srgbClr val="263442"/>
+                          </a:solidFill>
+                          <a:latin typeface="Calibri"/>
+                        </a:rPr>
+                        <a:t>Por acordar; revisión Grupo 06</a:t>
+                      </a:r>
+                    </a:p>
+                  </a:txBody>
+                  <a:tcPr anchor="ctr" marL="54864" marR="54864" marT="32004" marB="32004">
+                    <a:lnL w="9525" cap="flat" cmpd="sng" algn="ctr">
+                      <a:solidFill>
+                        <a:srgbClr val="C9D3DD"/>
+                      </a:solidFill>
+                      <a:prstDash val="solid"/>
+                    </a:lnL>
+                    <a:lnR w="9525" cap="flat" cmpd="sng" algn="ctr">
+                      <a:solidFill>
+                        <a:srgbClr val="C9D3DD"/>
+                      </a:solidFill>
+                      <a:prstDash val="solid"/>
+                    </a:lnR>
+                    <a:lnT w="9525" cap="flat" cmpd="sng" algn="ctr">
+                      <a:solidFill>
+                        <a:srgbClr val="C9D3DD"/>
+                      </a:solidFill>
+                      <a:prstDash val="solid"/>
+                    </a:lnT>
+                    <a:lnB w="9525" cap="flat" cmpd="sng" algn="ctr">
+                      <a:solidFill>
+                        <a:srgbClr val="C9D3DD"/>
+                      </a:solidFill>
+                      <a:prstDash val="solid"/>
+                    </a:lnB>
+                    <a:solidFill>
+                      <a:srgbClr val="F2F6F9"/>
+                    </a:solidFill>
+                  </a:tcPr>
+                </a:tc>
+                <a:tc>
+                  <a:txBody>
+                    <a:bodyPr wrap="square"/>
+                    <a:lstStyle/>
+                    <a:p>
+                      <a:pPr algn="l">
+                        <a:lnSpc>
+                          <a:spcPct val="100000"/>
+                        </a:lnSpc>
+                        <a:spcBef>
+                          <a:spcPts val="0"/>
+                        </a:spcBef>
+                        <a:spcAft>
+                          <a:spcPts val="0"/>
+                        </a:spcAft>
+                      </a:pPr>
+                      <a:r>
+                        <a:rPr sz="1050" b="0">
+                          <a:solidFill>
+                            <a:srgbClr val="263442"/>
+                          </a:solidFill>
+                          <a:latin typeface="Calibri"/>
+                        </a:rPr>
+                        <a:t>Asignar costos a productos sin regla</a:t>
+                      </a:r>
+                    </a:p>
+                  </a:txBody>
+                  <a:tcPr anchor="ctr" marL="54864" marR="54864" marT="32004" marB="32004">
+                    <a:lnL w="9525" cap="flat" cmpd="sng" algn="ctr">
+                      <a:solidFill>
+                        <a:srgbClr val="C9D3DD"/>
+                      </a:solidFill>
+                      <a:prstDash val="solid"/>
+                    </a:lnL>
+                    <a:lnR w="9525" cap="flat" cmpd="sng" algn="ctr">
+                      <a:solidFill>
+                        <a:srgbClr val="C9D3DD"/>
+                      </a:solidFill>
+                      <a:prstDash val="solid"/>
+                    </a:lnR>
+                    <a:lnT w="9525" cap="flat" cmpd="sng" algn="ctr">
+                      <a:solidFill>
+                        <a:srgbClr val="C9D3DD"/>
+                      </a:solidFill>
+                      <a:prstDash val="solid"/>
+                    </a:lnT>
+                    <a:lnB w="9525" cap="flat" cmpd="sng" algn="ctr">
+                      <a:solidFill>
+                        <a:srgbClr val="C9D3DD"/>
+                      </a:solidFill>
+                      <a:prstDash val="solid"/>
+                    </a:lnB>
+                    <a:solidFill>
+                      <a:srgbClr val="F2F6F9"/>
+                    </a:solidFill>
+                  </a:tcPr>
+                </a:tc>
+                <a:tc>
+                  <a:txBody>
+                    <a:bodyPr wrap="square"/>
+                    <a:lstStyle/>
+                    <a:p>
+                      <a:pPr algn="l">
+                        <a:lnSpc>
+                          <a:spcPct val="100000"/>
+                        </a:lnSpc>
+                        <a:spcBef>
+                          <a:spcPts val="0"/>
+                        </a:spcBef>
+                        <a:spcAft>
+                          <a:spcPts val="0"/>
+                        </a:spcAft>
+                      </a:pPr>
+                      <a:r>
+                        <a:rPr sz="1050" b="0">
+                          <a:solidFill>
+                            <a:srgbClr val="263442"/>
+                          </a:solidFill>
+                          <a:latin typeface="Calibri"/>
+                        </a:rPr>
+                        <a:t>No asignar; relación temporal en S06</a:t>
+                      </a:r>
+                    </a:p>
+                  </a:txBody>
+                  <a:tcPr anchor="ctr" marL="54864" marR="54864" marT="32004" marB="32004">
+                    <a:lnL w="9525" cap="flat" cmpd="sng" algn="ctr">
+                      <a:solidFill>
+                        <a:srgbClr val="C9D3DD"/>
+                      </a:solidFill>
+                      <a:prstDash val="solid"/>
+                    </a:lnL>
+                    <a:lnR w="9525" cap="flat" cmpd="sng" algn="ctr">
+                      <a:solidFill>
+                        <a:srgbClr val="C9D3DD"/>
+                      </a:solidFill>
+                      <a:prstDash val="solid"/>
+                    </a:lnR>
+                    <a:lnT w="9525" cap="flat" cmpd="sng" algn="ctr">
+                      <a:solidFill>
+                        <a:srgbClr val="C9D3DD"/>
+                      </a:solidFill>
+                      <a:prstDash val="solid"/>
+                    </a:lnT>
+                    <a:lnB w="9525" cap="flat" cmpd="sng" algn="ctr">
+                      <a:solidFill>
+                        <a:srgbClr val="C9D3DD"/>
+                      </a:solidFill>
+                      <a:prstDash val="solid"/>
+                    </a:lnB>
+                    <a:solidFill>
+                      <a:srgbClr val="F2F6F9"/>
+                    </a:solidFill>
+                  </a:tcPr>
+                </a:tc>
+              </a:tr>
+            </a:tbl>
+          </a:graphicData>
+        </a:graphic>
+      </p:graphicFrame>
     </p:spTree>
   </p:cSld>
   <p:clrMapOvr>

</xml_diff>